<commit_message>
docs(report): regenera a apresentação e o roteiro
</commit_message>
<xml_diff>
--- a/project/report/apresentacao.pptx
+++ b/project/report/apresentacao.pptx
@@ -826,6 +826,11 @@
           </a:p>
           <a:p>
             <a:r>
+              <a:t>Ferramenta e captura não se separam: o HKD traz outras ferramentas e outra captura.</a:t>
+            </a:r>
+          </a:p>
+          <a:p>
+            <a:r>
               <a:t>Os 99,42% são 510 de 513 fluxos, e medem as mesmas ferramentas, não uma nunca vista.</a:t>
             </a:r>
           </a:p>
@@ -889,12 +894,32 @@
           <a:lstStyle/>
           <a:p>
             <a:r>
-              <a:t>A é o sistema do artigo com profundidade variável; 10 seeds, média e desvio.</a:t>
-            </a:r>
-          </a:p>
-          <a:p>
-            <a:r>
-              <a:t>M1 perde 0,50 ponto de recall de Benign-DoH em relação a A.</a:t>
+              <a:t>A hipótese foi registrada antes da execução: sem amostras sintéticas e sem empilhamento, F1 macro maior por menos de 1 ponto, sem ganho esperado no recall de Benign-DoH.</a:t>
+            </a:r>
+          </a:p>
+          <a:p>
+            <a:r>
+              <a:t>A é o sistema do artigo com profundidade variável; 10 seeds, média e desvio, em %. Prec. Benign é a precisão de Benign-DoH.</a:t>
+            </a:r>
+          </a:p>
+          <a:p>
+            <a:r>
+              <a:t>A seleção escolheu a mesma combinação nas dez seeds, nos dois conjuntos: 100 árvores, sem limite de profundidade, raiz quadrada dos atributos por divisão.</a:t>
+            </a:r>
+          </a:p>
+          <a:p>
+            <a:r>
+              <a:t>M1 perde 0,50 ponto de recall de Benign-DoH e o FPR de Malicious-DoH vai de 0,0015% para 0,0048%.</a:t>
+            </a:r>
+          </a:p>
+          <a:p>
+            <a:r>
+              <a:t>Com profundidade 5, o modelo único recupera o recall de Benign-DoH (87,64%), mas com precisão de 26,23% e F1 macro de 78,66%.</a:t>
+            </a:r>
+          </a:p>
+          <a:p>
+            <a:r>
+              <a:t>Tempo: 1,6 vez no CIRA e 2,3 vezes no combinado; o tempo de A no CIRA foi medido sob outra carga e, reajustado, é 112,5 s (2,3 vezes).</a:t>
             </a:r>
           </a:p>
           <a:p>
@@ -962,6 +987,16 @@
           <a:lstStyle/>
           <a:p>
             <a:r>
+              <a:t>A e A-prof5 são o sistema do artigo com profundidade variável e com profundidade 5; M1M2 é a modificação.</a:t>
+            </a:r>
+          </a:p>
+          <a:p>
+            <a:r>
+              <a:t>O artigo publica que a duração pesa na decisão: é o que o atacante usaria.</a:t>
+            </a:r>
+          </a:p>
+          <a:p>
+            <a:r>
               <a:t>Nenhum tráfego foi gerado: é perturbação simulada, sem retreino.</a:t>
             </a:r>
           </a:p>
@@ -1030,12 +1065,17 @@
           <a:lstStyle/>
           <a:p>
             <a:r>
-              <a:t>A modificação melhora o F1 macro em meio ponto e não resolve a generalização.</a:t>
-            </a:r>
-          </a:p>
-          <a:p>
-            <a:r>
-              <a:t>O segundo dataset compartilha duas classes com o primeiro.</a:t>
+              <a:t>A modificação melhora o F1 macro em meio ponto e não resolve a detecção das ferramentas do HKD; sob fragmentação, seu recall cai em algumas seeds.</a:t>
+            </a:r>
+          </a:p>
+          <a:p>
+            <a:r>
+              <a:t>O segundo conjunto de dados compartilha duas classes com o primeiro.</a:t>
+            </a:r>
+          </a:p>
+          <a:p>
+            <a:r>
+              <a:t>Próximo passo: gerar tráfego fragmentado e testar uma ferramenta deixada de fora.</a:t>
             </a:r>
           </a:p>
           <a:p>
@@ -1161,7 +1201,7 @@
           </a:p>
           <a:p>
             <a:r>
-              <a:t>Artigo: Zebin, Rezvy e Luo, IEEE TIFS, 2022. Dataset CIRA-CIC-DoHBrw-2020.</a:t>
+              <a:t>Artigo: Zebin, Rezvy e Luo, IEEE TIFS, 2022. Conjunto de dados CIRA-CIC-DoHBrw-2020.</a:t>
             </a:r>
           </a:p>
           <a:p>
@@ -1234,7 +1274,17 @@
           </a:p>
           <a:p>
             <a:r>
-              <a:t>As etapas seguintes usam a leitura de profundidade variável como base, porque a outra não prediz uma das classes.</a:t>
+              <a:t>Os experimentos seguintes usam a leitura de profundidade variável como base, porque a outra não prediz uma das classes.</a:t>
+            </a:r>
+          </a:p>
+          <a:p>
+            <a:r>
+              <a:t>Protocolo corrigido: dez seeds em vez de uma, comparação pareada no mesmo split, teste sem vetores repetidos e folds por máquina.</a:t>
+            </a:r>
+          </a:p>
+          <a:p>
+            <a:r>
+              <a:t>Um script por experimento; resultado gravado com seed, versões e commit.</a:t>
             </a:r>
           </a:p>
         </p:txBody>
@@ -1365,11 +1415,6 @@
           </a:p>
           <a:p>
             <a:r>
-              <a:t>Trilha fiel é a profundidade 5; trilha variante, a profundidade variável.</a:t>
-            </a:r>
-          </a:p>
-          <a:p>
-            <a:r>
               <a:t>Com profundidade 5, os 1975 fluxos Benign-DoH do teste vão para Non-DoH.</a:t>
             </a:r>
           </a:p>
@@ -1443,7 +1488,7 @@
           </a:p>
           <a:p>
             <a:r>
-              <a:t>A combinação em que os três dizem Benign-DoH ocorre em 49247 linhas do treino; 31025 são Non-DoH. O meta-classificador devolve Non-DoH.</a:t>
+              <a:t>A combinação em que os três dizem Benign-DoH ocorre em 49247 fluxos do treino; 31025 são Non-DoH. O meta-classificador devolve Non-DoH.</a:t>
             </a:r>
           </a:p>
           <a:p>
@@ -1506,7 +1551,7 @@
           <a:lstStyle/>
           <a:p>
             <a:r>
-              <a:t>Art. é o valor do artigo; Rep. e Macro são a reprodução, com média macro.</a:t>
+              <a:t>A coluna do artigo é a da Tabela II; a da reprodução usa a média macro.</a:t>
             </a:r>
           </a:p>
           <a:p>
@@ -1574,7 +1619,12 @@
           <a:lstStyle/>
           <a:p>
             <a:r>
-              <a:t>Uma regra com um só atributo teria recall de 99,84% e 1 falso positivo em 909555 fluxos legítimos: o modelo pode separar pela captura.</a:t>
+              <a:t>Uma regra com um só atributo teria recall de 99,84% e 1 falso positivo em 909555 fluxos legítimos (Non-DoH e Benign-DoH): o modelo pode separar pela captura.</a:t>
+            </a:r>
+          </a:p>
+          <a:p>
+            <a:r>
+              <a:t>Acima de 40 s, têm SHAP positivo 97,37% dos fluxos com profundidade variável e 99,53% com profundidade 5.</a:t>
             </a:r>
           </a:p>
           <a:p>
@@ -1643,6 +1693,11 @@
           <a:p>
             <a:r>
               <a:t>Um ponto por seed; o traço é a média.</a:t>
+            </a:r>
+          </a:p>
+          <a:p>
+            <a:r>
+              <a:t>O que muda em relação à reprodução: dez seeds em vez de uma e comparação pareada no mesmo split; o SMOTE já era ajustado só no treino.</a:t>
             </a:r>
           </a:p>
           <a:p>
@@ -6441,7 +6496,7 @@
                 </a:solidFill>
                 <a:latin typeface="Proxima Nova"/>
               </a:rPr>
-              <a:t>Reprodução, segundo dataset e modificação</a:t>
+              <a:t>Reprodução, segundo conjunto de dados e modificação</a:t>
             </a:r>
           </a:p>
           <a:p>
@@ -6611,117 +6666,14 @@
                 </a:solidFill>
                 <a:latin typeface="Proxima Nova Extrabold"/>
               </a:rPr>
-              <a:t>Segundo dataset: ferramentas novas</a:t>
-            </a:r>
-          </a:p>
-        </p:txBody>
-      </p:sp>
-      <p:sp>
-        <p:nvSpPr>
-          <p:cNvPr id="4" name="TextBox 3"/>
-          <p:cNvSpPr txBox="1"/>
-          <p:nvPr/>
-        </p:nvSpPr>
-        <p:spPr>
-          <a:xfrm>
-            <a:off x="311700" y="1010000"/>
-            <a:ext cx="4000000" cy="3900000"/>
-          </a:xfrm>
-          <a:prstGeom prst="rect">
-            <a:avLst/>
-          </a:prstGeom>
-          <a:noFill/>
-        </p:spPr>
-        <p:txBody>
-          <a:bodyPr wrap="square">
-            <a:spAutoFit/>
-          </a:bodyPr>
-          <a:lstStyle/>
-          <a:p>
-            <a:pPr>
-              <a:spcAft>
-                <a:spcPts val="800"/>
-              </a:spcAft>
-            </a:pPr>
-            <a:r>
-              <a:rPr sz="1600" b="0">
-                <a:solidFill>
-                  <a:srgbClr val="231F20"/>
-                </a:solidFill>
-                <a:latin typeface="Proxima Nova"/>
-              </a:rPr>
-              <a:t>• Treinado no CIRA, o sistema detecta 1,81% dos fluxos do HKD</a:t>
-            </a:r>
-          </a:p>
-          <a:p>
-            <a:pPr>
-              <a:spcAft>
-                <a:spcPts val="800"/>
-              </a:spcAft>
-            </a:pPr>
-            <a:r>
-              <a:rPr sz="1600" b="0">
-                <a:solidFill>
-                  <a:srgbClr val="231F20"/>
-                </a:solidFill>
-                <a:latin typeface="Proxima Nova"/>
-              </a:rPr>
-              <a:t>• A regra de PacketLengthMode: 99,84% no CIRA, 0% no HKD</a:t>
-            </a:r>
-          </a:p>
-          <a:p>
-            <a:pPr>
-              <a:spcAft>
-                <a:spcPts val="800"/>
-              </a:spcAft>
-            </a:pPr>
-            <a:r>
-              <a:rPr sz="1600" b="0">
-                <a:solidFill>
-                  <a:srgbClr val="231F20"/>
-                </a:solidFill>
-                <a:latin typeface="Proxima Nova"/>
-              </a:rPr>
-              <a:t>• Retreino sem réplicas: 99,42%, em fluxos vizinhos dos do treino</a:t>
-            </a:r>
-          </a:p>
-          <a:p>
-            <a:pPr>
-              <a:spcAft>
-                <a:spcPts val="800"/>
-              </a:spcAft>
-            </a:pPr>
-            <a:r>
-              <a:rPr sz="1600" b="0">
-                <a:solidFill>
-                  <a:srgbClr val="231F20"/>
-                </a:solidFill>
-                <a:latin typeface="Proxima Nova"/>
-              </a:rPr>
-              <a:t>• Retreino no publicado: todo fluxo do HKD no teste tem cópia no treino</a:t>
-            </a:r>
-          </a:p>
-          <a:p>
-            <a:pPr>
-              <a:spcAft>
-                <a:spcPts val="800"/>
-              </a:spcAft>
-            </a:pPr>
-            <a:r>
-              <a:rPr sz="1600" b="0">
-                <a:solidFill>
-                  <a:srgbClr val="231F20"/>
-                </a:solidFill>
-                <a:latin typeface="Proxima Nova"/>
-              </a:rPr>
-              <a:t>• Com profundidade 5: 73,29% nas ferramentas do HKD</a:t>
+              <a:t>Segundo conjunto de dados: ferramentas novas</a:t>
             </a:r>
           </a:p>
         </p:txBody>
       </p:sp>
       <p:pic>
         <p:nvPicPr>
-          <p:cNvPr id="5" name="Picture 4" descr="segundo_recall_ferramenta.png"/>
+          <p:cNvPr id="4" name="Picture 3" descr="segundo_recall_ferramenta.png"/>
           <p:cNvPicPr>
             <a:picLocks noChangeAspect="1"/>
           </p:cNvPicPr>
@@ -6743,6 +6695,109 @@
           </a:prstGeom>
         </p:spPr>
       </p:pic>
+      <p:sp>
+        <p:nvSpPr>
+          <p:cNvPr id="5" name="TextBox 4"/>
+          <p:cNvSpPr txBox="1"/>
+          <p:nvPr/>
+        </p:nvSpPr>
+        <p:spPr>
+          <a:xfrm>
+            <a:off x="311700" y="1010000"/>
+            <a:ext cx="4000000" cy="3900000"/>
+          </a:xfrm>
+          <a:prstGeom prst="rect">
+            <a:avLst/>
+          </a:prstGeom>
+          <a:noFill/>
+        </p:spPr>
+        <p:txBody>
+          <a:bodyPr wrap="square">
+            <a:spAutoFit/>
+          </a:bodyPr>
+          <a:lstStyle/>
+          <a:p>
+            <a:pPr>
+              <a:spcAft>
+                <a:spcPts val="800"/>
+              </a:spcAft>
+            </a:pPr>
+            <a:r>
+              <a:rPr sz="1600" b="0">
+                <a:solidFill>
+                  <a:srgbClr val="231F20"/>
+                </a:solidFill>
+                <a:latin typeface="Proxima Nova"/>
+              </a:rPr>
+              <a:t>• Treinado no CIRA, o sistema detecta 1,81% dos fluxos do HKD</a:t>
+            </a:r>
+          </a:p>
+          <a:p>
+            <a:pPr>
+              <a:spcAft>
+                <a:spcPts val="800"/>
+              </a:spcAft>
+            </a:pPr>
+            <a:r>
+              <a:rPr sz="1600" b="0">
+                <a:solidFill>
+                  <a:srgbClr val="231F20"/>
+                </a:solidFill>
+                <a:latin typeface="Proxima Nova"/>
+              </a:rPr>
+              <a:t>• A regra de PacketLengthMode: 99,84% no CIRA, 0% no HKD</a:t>
+            </a:r>
+          </a:p>
+          <a:p>
+            <a:pPr>
+              <a:spcAft>
+                <a:spcPts val="800"/>
+              </a:spcAft>
+            </a:pPr>
+            <a:r>
+              <a:rPr sz="1600" b="0">
+                <a:solidFill>
+                  <a:srgbClr val="231F20"/>
+                </a:solidFill>
+                <a:latin typeface="Proxima Nova"/>
+              </a:rPr>
+              <a:t>• Retreino sem réplicas: 99,42%, em fluxos vizinhos dos do treino</a:t>
+            </a:r>
+          </a:p>
+          <a:p>
+            <a:pPr>
+              <a:spcAft>
+                <a:spcPts val="800"/>
+              </a:spcAft>
+            </a:pPr>
+            <a:r>
+              <a:rPr sz="1600" b="0">
+                <a:solidFill>
+                  <a:srgbClr val="231F20"/>
+                </a:solidFill>
+                <a:latin typeface="Proxima Nova"/>
+              </a:rPr>
+              <a:t>• Retreino no publicado: todo fluxo do HKD no teste tem cópia no treino</a:t>
+            </a:r>
+          </a:p>
+          <a:p>
+            <a:pPr>
+              <a:spcAft>
+                <a:spcPts val="800"/>
+              </a:spcAft>
+            </a:pPr>
+            <a:r>
+              <a:rPr sz="1600" b="0">
+                <a:solidFill>
+                  <a:srgbClr val="231F20"/>
+                </a:solidFill>
+                <a:latin typeface="Proxima Nova"/>
+              </a:rPr>
+              <a:t>• Com profundidade 5: 73,29% nas ferramentas do HKD</a:t>
+            </a:r>
+          </a:p>
+        </p:txBody>
+      </p:sp>
     </p:spTree>
   </p:cSld>
   <p:clrMapOvr>
@@ -6841,96 +6896,9 @@
           </a:p>
         </p:txBody>
       </p:sp>
-      <p:sp>
-        <p:nvSpPr>
-          <p:cNvPr id="4" name="TextBox 3"/>
-          <p:cNvSpPr txBox="1"/>
-          <p:nvPr/>
-        </p:nvSpPr>
-        <p:spPr>
-          <a:xfrm>
-            <a:off x="311700" y="3590000"/>
-            <a:ext cx="8520600" cy="1403500"/>
-          </a:xfrm>
-          <a:prstGeom prst="rect">
-            <a:avLst/>
-          </a:prstGeom>
-          <a:noFill/>
-        </p:spPr>
-        <p:txBody>
-          <a:bodyPr wrap="square">
-            <a:spAutoFit/>
-          </a:bodyPr>
-          <a:lstStyle/>
-          <a:p>
-            <a:pPr>
-              <a:spcAft>
-                <a:spcPts val="800"/>
-              </a:spcAft>
-            </a:pPr>
-            <a:r>
-              <a:rPr sz="1600" b="0">
-                <a:solidFill>
-                  <a:srgbClr val="231F20"/>
-                </a:solidFill>
-                <a:latin typeface="Proxima Nova"/>
-              </a:rPr>
-              <a:t>• Sem SMOTE e sem empilhamento; M1M2 também seleciona hiperparâmetros</a:t>
-            </a:r>
-          </a:p>
-          <a:p>
-            <a:pPr>
-              <a:spcAft>
-                <a:spcPts val="800"/>
-              </a:spcAft>
-            </a:pPr>
-            <a:r>
-              <a:rPr sz="1600" b="0">
-                <a:solidFill>
-                  <a:srgbClr val="231F20"/>
-                </a:solidFill>
-                <a:latin typeface="Proxima Nova"/>
-              </a:rPr>
-              <a:t>• F1 macro 0,50 ponto acima no CIRA e 0,57 no combinado, nas dez seeds</a:t>
-            </a:r>
-          </a:p>
-          <a:p>
-            <a:pPr>
-              <a:spcAft>
-                <a:spcPts val="800"/>
-              </a:spcAft>
-            </a:pPr>
-            <a:r>
-              <a:rPr sz="1600" b="0">
-                <a:solidFill>
-                  <a:srgbClr val="231F20"/>
-                </a:solidFill>
-                <a:latin typeface="Proxima Nova"/>
-              </a:rPr>
-              <a:t>• O ganho já está em M1, que treina em 31 s</a:t>
-            </a:r>
-          </a:p>
-          <a:p>
-            <a:pPr>
-              <a:spcAft>
-                <a:spcPts val="800"/>
-              </a:spcAft>
-            </a:pPr>
-            <a:r>
-              <a:rPr sz="1600" b="0">
-                <a:solidFill>
-                  <a:srgbClr val="231F20"/>
-                </a:solidFill>
-                <a:latin typeface="Proxima Nova"/>
-              </a:rPr>
-              <a:t>• A seleção de hiperparâmetros não muda o F1 macro: −0,08 ± 0,15 ponto</a:t>
-            </a:r>
-          </a:p>
-        </p:txBody>
-      </p:sp>
       <p:graphicFrame>
         <p:nvGraphicFramePr>
-          <p:cNvPr id="5" name="Table 4"/>
+          <p:cNvPr id="4" name="Table 3"/>
           <p:cNvGraphicFramePr>
             <a:graphicFrameLocks noGrp="1"/>
           </p:cNvGraphicFramePr>
@@ -6938,7 +6906,7 @@
         </p:nvGraphicFramePr>
         <p:xfrm>
           <a:off x="311700" y="1010000"/>
-          <a:ext cx="7924156" cy="1980000"/>
+          <a:ext cx="7924157" cy="1800000"/>
         </p:xfrm>
         <a:graphic>
           <a:graphicData uri="http://schemas.openxmlformats.org/drawingml/2006/table">
@@ -6948,13 +6916,12 @@
               </a:tblPr>
               <a:tblGrid>
                 <a:gridCol w="2060281"/>
-                <a:gridCol w="1172775"/>
-                <a:gridCol w="1172775"/>
-                <a:gridCol w="1172775"/>
-                <a:gridCol w="1172775"/>
-                <a:gridCol w="1172775"/>
+                <a:gridCol w="1465969"/>
+                <a:gridCol w="1465969"/>
+                <a:gridCol w="1465969"/>
+                <a:gridCol w="1465969"/>
               </a:tblGrid>
-              <a:tr h="330000">
+              <a:tr h="300000">
                 <a:tc>
                   <a:txBody>
                     <a:bodyPr wrap="square"/>
@@ -6966,13 +6933,13 @@
                         </a:spcAft>
                       </a:pPr>
                       <a:r>
-                        <a:rPr sz="1100" b="1">
+                        <a:rPr sz="1400" b="1">
                           <a:solidFill>
                             <a:srgbClr val="FFFFFF"/>
                           </a:solidFill>
                           <a:latin typeface="Proxima Nova"/>
                         </a:rPr>
-                        <a:t>Dataset</a:t>
+                        <a:t>Conjunto</a:t>
                       </a:r>
                     </a:p>
                   </a:txBody>
@@ -6993,7 +6960,7 @@
                         </a:spcAft>
                       </a:pPr>
                       <a:r>
-                        <a:rPr sz="1100" b="1">
+                        <a:rPr sz="1400" b="1">
                           <a:solidFill>
                             <a:srgbClr val="FFFFFF"/>
                           </a:solidFill>
@@ -7020,13 +6987,13 @@
                         </a:spcAft>
                       </a:pPr>
                       <a:r>
-                        <a:rPr sz="1100" b="1">
+                        <a:rPr sz="1400" b="1">
                           <a:solidFill>
                             <a:srgbClr val="FFFFFF"/>
                           </a:solidFill>
                           <a:latin typeface="Proxima Nova"/>
                         </a:rPr>
-                        <a:t>Benign prec.</a:t>
+                        <a:t>Prec. Benign</a:t>
                       </a:r>
                     </a:p>
                   </a:txBody>
@@ -7047,34 +7014,7 @@
                         </a:spcAft>
                       </a:pPr>
                       <a:r>
-                        <a:rPr sz="1100" b="1">
-                          <a:solidFill>
-                            <a:srgbClr val="FFFFFF"/>
-                          </a:solidFill>
-                          <a:latin typeface="Proxima Nova"/>
-                        </a:rPr>
-                        <a:t>Benign rec.</a:t>
-                      </a:r>
-                    </a:p>
-                  </a:txBody>
-                  <a:tcPr marT="30000" marB="30000">
-                    <a:solidFill>
-                      <a:srgbClr val="231F20"/>
-                    </a:solidFill>
-                  </a:tcPr>
-                </a:tc>
-                <a:tc>
-                  <a:txBody>
-                    <a:bodyPr wrap="square"/>
-                    <a:lstStyle/>
-                    <a:p>
-                      <a:pPr>
-                        <a:spcAft>
-                          <a:spcPts val="0"/>
-                        </a:spcAft>
-                      </a:pPr>
-                      <a:r>
-                        <a:rPr sz="1100" b="1">
+                        <a:rPr sz="1400" b="1">
                           <a:solidFill>
                             <a:srgbClr val="FFFFFF"/>
                           </a:solidFill>
@@ -7101,7 +7041,7 @@
                         </a:spcAft>
                       </a:pPr>
                       <a:r>
-                        <a:rPr sz="1100" b="1">
+                        <a:rPr sz="1400" b="1">
                           <a:solidFill>
                             <a:srgbClr val="FFFFFF"/>
                           </a:solidFill>
@@ -7118,7 +7058,7 @@
                   </a:tcPr>
                 </a:tc>
               </a:tr>
-              <a:tr h="330000">
+              <a:tr h="300000">
                 <a:tc>
                   <a:txBody>
                     <a:bodyPr wrap="square"/>
@@ -7130,7 +7070,7 @@
                         </a:spcAft>
                       </a:pPr>
                       <a:r>
-                        <a:rPr sz="1100" b="0">
+                        <a:rPr sz="1400" b="0">
                           <a:solidFill>
                             <a:srgbClr val="231F20"/>
                           </a:solidFill>
@@ -7157,7 +7097,7 @@
                         </a:spcAft>
                       </a:pPr>
                       <a:r>
-                        <a:rPr sz="1100" b="0">
+                        <a:rPr sz="1400" b="0">
                           <a:solidFill>
                             <a:srgbClr val="231F20"/>
                           </a:solidFill>
@@ -7184,7 +7124,7 @@
                         </a:spcAft>
                       </a:pPr>
                       <a:r>
-                        <a:rPr sz="1100" b="0">
+                        <a:rPr sz="1400" b="0">
                           <a:solidFill>
                             <a:srgbClr val="231F20"/>
                           </a:solidFill>
@@ -7211,34 +7151,7 @@
                         </a:spcAft>
                       </a:pPr>
                       <a:r>
-                        <a:rPr sz="1100" b="0">
-                          <a:solidFill>
-                            <a:srgbClr val="231F20"/>
-                          </a:solidFill>
-                          <a:latin typeface="Proxima Nova"/>
-                        </a:rPr>
-                        <a:t>93,07 ± 0,52</a:t>
-                      </a:r>
-                    </a:p>
-                  </a:txBody>
-                  <a:tcPr marT="30000" marB="30000">
-                    <a:solidFill>
-                      <a:srgbClr val="FFFFFF"/>
-                    </a:solidFill>
-                  </a:tcPr>
-                </a:tc>
-                <a:tc>
-                  <a:txBody>
-                    <a:bodyPr wrap="square"/>
-                    <a:lstStyle/>
-                    <a:p>
-                      <a:pPr>
-                        <a:spcAft>
-                          <a:spcPts val="0"/>
-                        </a:spcAft>
-                      </a:pPr>
-                      <a:r>
-                        <a:rPr sz="1100" b="0">
+                        <a:rPr sz="1400" b="0">
                           <a:solidFill>
                             <a:srgbClr val="231F20"/>
                           </a:solidFill>
@@ -7265,7 +7178,7 @@
                         </a:spcAft>
                       </a:pPr>
                       <a:r>
-                        <a:rPr sz="1100" b="0">
+                        <a:rPr sz="1400" b="0">
                           <a:solidFill>
                             <a:srgbClr val="231F20"/>
                           </a:solidFill>
@@ -7282,7 +7195,7 @@
                   </a:tcPr>
                 </a:tc>
               </a:tr>
-              <a:tr h="330000">
+              <a:tr h="300000">
                 <a:tc>
                   <a:txBody>
                     <a:bodyPr wrap="square"/>
@@ -7294,7 +7207,7 @@
                         </a:spcAft>
                       </a:pPr>
                       <a:r>
-                        <a:rPr sz="1100" b="0">
+                        <a:rPr sz="1400" b="0">
                           <a:solidFill>
                             <a:srgbClr val="231F20"/>
                           </a:solidFill>
@@ -7321,7 +7234,7 @@
                         </a:spcAft>
                       </a:pPr>
                       <a:r>
-                        <a:rPr sz="1100" b="0">
+                        <a:rPr sz="1400" b="0">
                           <a:solidFill>
                             <a:srgbClr val="231F20"/>
                           </a:solidFill>
@@ -7348,7 +7261,7 @@
                         </a:spcAft>
                       </a:pPr>
                       <a:r>
-                        <a:rPr sz="1100" b="0">
+                        <a:rPr sz="1400" b="0">
                           <a:solidFill>
                             <a:srgbClr val="231F20"/>
                           </a:solidFill>
@@ -7375,34 +7288,7 @@
                         </a:spcAft>
                       </a:pPr>
                       <a:r>
-                        <a:rPr sz="1100" b="0">
-                          <a:solidFill>
-                            <a:srgbClr val="231F20"/>
-                          </a:solidFill>
-                          <a:latin typeface="Proxima Nova"/>
-                        </a:rPr>
-                        <a:t>92,57 ± 0,51</a:t>
-                      </a:r>
-                    </a:p>
-                  </a:txBody>
-                  <a:tcPr marT="30000" marB="30000">
-                    <a:solidFill>
-                      <a:srgbClr val="EEEEEE"/>
-                    </a:solidFill>
-                  </a:tcPr>
-                </a:tc>
-                <a:tc>
-                  <a:txBody>
-                    <a:bodyPr wrap="square"/>
-                    <a:lstStyle/>
-                    <a:p>
-                      <a:pPr>
-                        <a:spcAft>
-                          <a:spcPts val="0"/>
-                        </a:spcAft>
-                      </a:pPr>
-                      <a:r>
-                        <a:rPr sz="1100" b="0">
+                        <a:rPr sz="1400" b="0">
                           <a:solidFill>
                             <a:srgbClr val="231F20"/>
                           </a:solidFill>
@@ -7429,7 +7315,7 @@
                         </a:spcAft>
                       </a:pPr>
                       <a:r>
-                        <a:rPr sz="1100" b="0">
+                        <a:rPr sz="1400" b="0">
                           <a:solidFill>
                             <a:srgbClr val="231F20"/>
                           </a:solidFill>
@@ -7446,7 +7332,7 @@
                   </a:tcPr>
                 </a:tc>
               </a:tr>
-              <a:tr h="330000">
+              <a:tr h="300000">
                 <a:tc>
                   <a:txBody>
                     <a:bodyPr wrap="square"/>
@@ -7458,7 +7344,7 @@
                         </a:spcAft>
                       </a:pPr>
                       <a:r>
-                        <a:rPr sz="1100" b="0">
+                        <a:rPr sz="1400" b="0">
                           <a:solidFill>
                             <a:srgbClr val="231F20"/>
                           </a:solidFill>
@@ -7485,7 +7371,7 @@
                         </a:spcAft>
                       </a:pPr>
                       <a:r>
-                        <a:rPr sz="1100" b="0">
+                        <a:rPr sz="1400" b="0">
                           <a:solidFill>
                             <a:srgbClr val="231F20"/>
                           </a:solidFill>
@@ -7512,7 +7398,7 @@
                         </a:spcAft>
                       </a:pPr>
                       <a:r>
-                        <a:rPr sz="1100" b="0">
+                        <a:rPr sz="1400" b="0">
                           <a:solidFill>
                             <a:srgbClr val="231F20"/>
                           </a:solidFill>
@@ -7539,34 +7425,7 @@
                         </a:spcAft>
                       </a:pPr>
                       <a:r>
-                        <a:rPr sz="1100" b="0">
-                          <a:solidFill>
-                            <a:srgbClr val="231F20"/>
-                          </a:solidFill>
-                          <a:latin typeface="Proxima Nova"/>
-                        </a:rPr>
-                        <a:t>93,67 ± 0,48</a:t>
-                      </a:r>
-                    </a:p>
-                  </a:txBody>
-                  <a:tcPr marT="30000" marB="30000">
-                    <a:solidFill>
-                      <a:srgbClr val="FFFFFF"/>
-                    </a:solidFill>
-                  </a:tcPr>
-                </a:tc>
-                <a:tc>
-                  <a:txBody>
-                    <a:bodyPr wrap="square"/>
-                    <a:lstStyle/>
-                    <a:p>
-                      <a:pPr>
-                        <a:spcAft>
-                          <a:spcPts val="0"/>
-                        </a:spcAft>
-                      </a:pPr>
-                      <a:r>
-                        <a:rPr sz="1100" b="0">
+                        <a:rPr sz="1400" b="0">
                           <a:solidFill>
                             <a:srgbClr val="231F20"/>
                           </a:solidFill>
@@ -7593,7 +7452,7 @@
                         </a:spcAft>
                       </a:pPr>
                       <a:r>
-                        <a:rPr sz="1100" b="0">
+                        <a:rPr sz="1400" b="0">
                           <a:solidFill>
                             <a:srgbClr val="231F20"/>
                           </a:solidFill>
@@ -7610,7 +7469,7 @@
                   </a:tcPr>
                 </a:tc>
               </a:tr>
-              <a:tr h="330000">
+              <a:tr h="300000">
                 <a:tc>
                   <a:txBody>
                     <a:bodyPr wrap="square"/>
@@ -7622,13 +7481,13 @@
                         </a:spcAft>
                       </a:pPr>
                       <a:r>
-                        <a:rPr sz="1100" b="0">
+                        <a:rPr sz="1400" b="0">
                           <a:solidFill>
                             <a:srgbClr val="231F20"/>
                           </a:solidFill>
                           <a:latin typeface="Proxima Nova"/>
                         </a:rPr>
-                        <a:t>Combinado sem réplicas</a:t>
+                        <a:t>Combinado</a:t>
                       </a:r>
                     </a:p>
                   </a:txBody>
@@ -7649,7 +7508,7 @@
                         </a:spcAft>
                       </a:pPr>
                       <a:r>
-                        <a:rPr sz="1100" b="0">
+                        <a:rPr sz="1400" b="0">
                           <a:solidFill>
                             <a:srgbClr val="231F20"/>
                           </a:solidFill>
@@ -7676,7 +7535,7 @@
                         </a:spcAft>
                       </a:pPr>
                       <a:r>
-                        <a:rPr sz="1100" b="0">
+                        <a:rPr sz="1400" b="0">
                           <a:solidFill>
                             <a:srgbClr val="231F20"/>
                           </a:solidFill>
@@ -7703,34 +7562,7 @@
                         </a:spcAft>
                       </a:pPr>
                       <a:r>
-                        <a:rPr sz="1100" b="0">
-                          <a:solidFill>
-                            <a:srgbClr val="231F20"/>
-                          </a:solidFill>
-                          <a:latin typeface="Proxima Nova"/>
-                        </a:rPr>
-                        <a:t>93,18 ± 0,53</a:t>
-                      </a:r>
-                    </a:p>
-                  </a:txBody>
-                  <a:tcPr marT="30000" marB="30000">
-                    <a:solidFill>
-                      <a:srgbClr val="EEEEEE"/>
-                    </a:solidFill>
-                  </a:tcPr>
-                </a:tc>
-                <a:tc>
-                  <a:txBody>
-                    <a:bodyPr wrap="square"/>
-                    <a:lstStyle/>
-                    <a:p>
-                      <a:pPr>
-                        <a:spcAft>
-                          <a:spcPts val="0"/>
-                        </a:spcAft>
-                      </a:pPr>
-                      <a:r>
-                        <a:rPr sz="1100" b="0">
+                        <a:rPr sz="1400" b="0">
                           <a:solidFill>
                             <a:srgbClr val="231F20"/>
                           </a:solidFill>
@@ -7757,7 +7589,7 @@
                         </a:spcAft>
                       </a:pPr>
                       <a:r>
-                        <a:rPr sz="1100" b="0">
+                        <a:rPr sz="1400" b="0">
                           <a:solidFill>
                             <a:srgbClr val="231F20"/>
                           </a:solidFill>
@@ -7774,7 +7606,7 @@
                   </a:tcPr>
                 </a:tc>
               </a:tr>
-              <a:tr h="330000">
+              <a:tr h="300000">
                 <a:tc>
                   <a:txBody>
                     <a:bodyPr wrap="square"/>
@@ -7786,13 +7618,13 @@
                         </a:spcAft>
                       </a:pPr>
                       <a:r>
-                        <a:rPr sz="1100" b="0">
+                        <a:rPr sz="1400" b="0">
                           <a:solidFill>
                             <a:srgbClr val="231F20"/>
                           </a:solidFill>
                           <a:latin typeface="Proxima Nova"/>
                         </a:rPr>
-                        <a:t>Combinado sem réplicas</a:t>
+                        <a:t>Combinado</a:t>
                       </a:r>
                     </a:p>
                   </a:txBody>
@@ -7813,7 +7645,7 @@
                         </a:spcAft>
                       </a:pPr>
                       <a:r>
-                        <a:rPr sz="1100" b="0">
+                        <a:rPr sz="1400" b="0">
                           <a:solidFill>
                             <a:srgbClr val="231F20"/>
                           </a:solidFill>
@@ -7840,7 +7672,7 @@
                         </a:spcAft>
                       </a:pPr>
                       <a:r>
-                        <a:rPr sz="1100" b="0">
+                        <a:rPr sz="1400" b="0">
                           <a:solidFill>
                             <a:srgbClr val="231F20"/>
                           </a:solidFill>
@@ -7867,34 +7699,7 @@
                         </a:spcAft>
                       </a:pPr>
                       <a:r>
-                        <a:rPr sz="1100" b="0">
-                          <a:solidFill>
-                            <a:srgbClr val="231F20"/>
-                          </a:solidFill>
-                          <a:latin typeface="Proxima Nova"/>
-                        </a:rPr>
-                        <a:t>93,65 ± 0,40</a:t>
-                      </a:r>
-                    </a:p>
-                  </a:txBody>
-                  <a:tcPr marT="30000" marB="30000">
-                    <a:solidFill>
-                      <a:srgbClr val="FFFFFF"/>
-                    </a:solidFill>
-                  </a:tcPr>
-                </a:tc>
-                <a:tc>
-                  <a:txBody>
-                    <a:bodyPr wrap="square"/>
-                    <a:lstStyle/>
-                    <a:p>
-                      <a:pPr>
-                        <a:spcAft>
-                          <a:spcPts val="0"/>
-                        </a:spcAft>
-                      </a:pPr>
-                      <a:r>
-                        <a:rPr sz="1100" b="0">
+                        <a:rPr sz="1400" b="0">
                           <a:solidFill>
                             <a:srgbClr val="231F20"/>
                           </a:solidFill>
@@ -7921,7 +7726,7 @@
                         </a:spcAft>
                       </a:pPr>
                       <a:r>
-                        <a:rPr sz="1100" b="0">
+                        <a:rPr sz="1400" b="0">
                           <a:solidFill>
                             <a:srgbClr val="231F20"/>
                           </a:solidFill>
@@ -7942,6 +7747,109 @@
           </a:graphicData>
         </a:graphic>
       </p:graphicFrame>
+      <p:sp>
+        <p:nvSpPr>
+          <p:cNvPr id="5" name="TextBox 4"/>
+          <p:cNvSpPr txBox="1"/>
+          <p:nvPr/>
+        </p:nvSpPr>
+        <p:spPr>
+          <a:xfrm>
+            <a:off x="311700" y="2910000"/>
+            <a:ext cx="8520600" cy="2083500"/>
+          </a:xfrm>
+          <a:prstGeom prst="rect">
+            <a:avLst/>
+          </a:prstGeom>
+          <a:noFill/>
+        </p:spPr>
+        <p:txBody>
+          <a:bodyPr wrap="square">
+            <a:spAutoFit/>
+          </a:bodyPr>
+          <a:lstStyle/>
+          <a:p>
+            <a:pPr>
+              <a:spcAft>
+                <a:spcPts val="800"/>
+              </a:spcAft>
+            </a:pPr>
+            <a:r>
+              <a:rPr sz="1600" b="0">
+                <a:solidFill>
+                  <a:srgbClr val="231F20"/>
+                </a:solidFill>
+                <a:latin typeface="Proxima Nova"/>
+              </a:rPr>
+              <a:t>• Hipótese, escrita antes: sem SMOTE, F1 macro maior, por menos de 1 ponto</a:t>
+            </a:r>
+          </a:p>
+          <a:p>
+            <a:pPr>
+              <a:spcAft>
+                <a:spcPts val="800"/>
+              </a:spcAft>
+            </a:pPr>
+            <a:r>
+              <a:rPr sz="1600" b="0">
+                <a:solidFill>
+                  <a:srgbClr val="231F20"/>
+                </a:solidFill>
+                <a:latin typeface="Proxima Nova"/>
+              </a:rPr>
+              <a:t>• M1: Random Forest único com peso de classe; M1M2: M1 com seleção de hiperparâmetros</a:t>
+            </a:r>
+          </a:p>
+          <a:p>
+            <a:pPr>
+              <a:spcAft>
+                <a:spcPts val="800"/>
+              </a:spcAft>
+            </a:pPr>
+            <a:r>
+              <a:rPr sz="1600" b="0">
+                <a:solidFill>
+                  <a:srgbClr val="231F20"/>
+                </a:solidFill>
+                <a:latin typeface="Proxima Nova"/>
+              </a:rPr>
+              <a:t>• Resultado: F1 macro 0,50 ponto acima no CIRA e 0,57 no combinado, nas dez seeds</a:t>
+            </a:r>
+          </a:p>
+          <a:p>
+            <a:pPr>
+              <a:spcAft>
+                <a:spcPts val="800"/>
+              </a:spcAft>
+            </a:pPr>
+            <a:r>
+              <a:rPr sz="1600" b="0">
+                <a:solidFill>
+                  <a:srgbClr val="231F20"/>
+                </a:solidFill>
+                <a:latin typeface="Proxima Nova"/>
+              </a:rPr>
+              <a:t>• O ganho já está em M1; a seleção não muda o F1 macro: −0,08 ± 0,15 ponto</a:t>
+            </a:r>
+          </a:p>
+          <a:p>
+            <a:pPr>
+              <a:spcAft>
+                <a:spcPts val="800"/>
+              </a:spcAft>
+            </a:pPr>
+            <a:r>
+              <a:rPr sz="1600" b="0">
+                <a:solidFill>
+                  <a:srgbClr val="231F20"/>
+                </a:solidFill>
+                <a:latin typeface="Proxima Nova"/>
+              </a:rPr>
+              <a:t>• Custo: M1 piora o FPR de Malicious-DoH; M1M2 treina em 1,6 a 2,3 vezes o tempo de A</a:t>
+            </a:r>
+          </a:p>
+        </p:txBody>
+      </p:sp>
     </p:spTree>
   </p:cSld>
   <p:clrMapOvr>
@@ -8040,112 +7948,9 @@
           </a:p>
         </p:txBody>
       </p:sp>
-      <p:sp>
-        <p:nvSpPr>
-          <p:cNvPr id="4" name="TextBox 3"/>
-          <p:cNvSpPr txBox="1"/>
-          <p:nvPr/>
-        </p:nvSpPr>
-        <p:spPr>
-          <a:xfrm>
-            <a:off x="311700" y="1010000"/>
-            <a:ext cx="4000000" cy="3900000"/>
-          </a:xfrm>
-          <a:prstGeom prst="rect">
-            <a:avLst/>
-          </a:prstGeom>
-          <a:noFill/>
-        </p:spPr>
-        <p:txBody>
-          <a:bodyPr wrap="square">
-            <a:spAutoFit/>
-          </a:bodyPr>
-          <a:lstStyle/>
-          <a:p>
-            <a:pPr>
-              <a:spcAft>
-                <a:spcPts val="800"/>
-              </a:spcAft>
-            </a:pPr>
-            <a:r>
-              <a:rPr sz="1600" b="0">
-                <a:solidFill>
-                  <a:srgbClr val="231F20"/>
-                </a:solidFill>
-                <a:latin typeface="Proxima Nova"/>
-              </a:rPr>
-              <a:t>• O artigo publica que a duração pesa: o atacante encurta o fluxo</a:t>
-            </a:r>
-          </a:p>
-          <a:p>
-            <a:pPr>
-              <a:spcAft>
-                <a:spcPts val="800"/>
-              </a:spcAft>
-            </a:pPr>
-            <a:r>
-              <a:rPr sz="1600" b="0">
-                <a:solidFill>
-                  <a:srgbClr val="231F20"/>
-                </a:solidFill>
-                <a:latin typeface="Proxima Nova"/>
-              </a:rPr>
-              <a:t>• Duração e bytes divididos por k, no espaço de atributos</a:t>
-            </a:r>
-          </a:p>
-          <a:p>
-            <a:pPr>
-              <a:spcAft>
-                <a:spcPts val="800"/>
-              </a:spcAft>
-            </a:pPr>
-            <a:r>
-              <a:rPr sz="1600" b="0">
-                <a:solidFill>
-                  <a:srgbClr val="231F20"/>
-                </a:solidFill>
-                <a:latin typeface="Proxima Nova"/>
-              </a:rPr>
-              <a:t>• k = 2: o sistema do artigo perde 3,19 pontos de recall; M1M2, 0,34</a:t>
-            </a:r>
-          </a:p>
-          <a:p>
-            <a:pPr>
-              <a:spcAft>
-                <a:spcPts val="800"/>
-              </a:spcAft>
-            </a:pPr>
-            <a:r>
-              <a:rPr sz="1600" b="0">
-                <a:solidFill>
-                  <a:srgbClr val="231F20"/>
-                </a:solidFill>
-                <a:latin typeface="Proxima Nova"/>
-              </a:rPr>
-              <a:t>• k ≥ 4: M1M2 desaba em duas ou três seeds</a:t>
-            </a:r>
-          </a:p>
-          <a:p>
-            <a:pPr>
-              <a:spcAft>
-                <a:spcPts val="800"/>
-              </a:spcAft>
-            </a:pPr>
-            <a:r>
-              <a:rPr sz="1600" b="0">
-                <a:solidFill>
-                  <a:srgbClr val="231F20"/>
-                </a:solidFill>
-                <a:latin typeface="Proxima Nova"/>
-              </a:rPr>
-              <a:t>• Não ordena os modelos em robustez</a:t>
-            </a:r>
-          </a:p>
-        </p:txBody>
-      </p:sp>
       <p:pic>
         <p:nvPicPr>
-          <p:cNvPr id="5" name="Picture 4" descr="robustez_fragmentacao.png"/>
+          <p:cNvPr id="4" name="Picture 3" descr="robustez_fragmentacao.png"/>
           <p:cNvPicPr>
             <a:picLocks noChangeAspect="1"/>
           </p:cNvPicPr>
@@ -8167,6 +7972,109 @@
           </a:prstGeom>
         </p:spPr>
       </p:pic>
+      <p:sp>
+        <p:nvSpPr>
+          <p:cNvPr id="5" name="TextBox 4"/>
+          <p:cNvSpPr txBox="1"/>
+          <p:nvPr/>
+        </p:nvSpPr>
+        <p:spPr>
+          <a:xfrm>
+            <a:off x="311700" y="1010000"/>
+            <a:ext cx="4000000" cy="3900000"/>
+          </a:xfrm>
+          <a:prstGeom prst="rect">
+            <a:avLst/>
+          </a:prstGeom>
+          <a:noFill/>
+        </p:spPr>
+        <p:txBody>
+          <a:bodyPr wrap="square">
+            <a:spAutoFit/>
+          </a:bodyPr>
+          <a:lstStyle/>
+          <a:p>
+            <a:pPr>
+              <a:spcAft>
+                <a:spcPts val="800"/>
+              </a:spcAft>
+            </a:pPr>
+            <a:r>
+              <a:rPr sz="1600" b="0">
+                <a:solidFill>
+                  <a:srgbClr val="231F20"/>
+                </a:solidFill>
+                <a:latin typeface="Proxima Nova"/>
+              </a:rPr>
+              <a:t>• O atacante encurta o fluxo: duração e bytes divididos por k, no espaço de atributos</a:t>
+            </a:r>
+          </a:p>
+          <a:p>
+            <a:pPr>
+              <a:spcAft>
+                <a:spcPts val="800"/>
+              </a:spcAft>
+            </a:pPr>
+            <a:r>
+              <a:rPr sz="1600" b="0">
+                <a:solidFill>
+                  <a:srgbClr val="231F20"/>
+                </a:solidFill>
+                <a:latin typeface="Proxima Nova"/>
+              </a:rPr>
+              <a:t>• k = 2: o sistema do artigo perde 3,19 pontos de recall; M1M2, 0,34</a:t>
+            </a:r>
+          </a:p>
+          <a:p>
+            <a:pPr>
+              <a:spcAft>
+                <a:spcPts val="800"/>
+              </a:spcAft>
+            </a:pPr>
+            <a:r>
+              <a:rPr sz="1600" b="0">
+                <a:solidFill>
+                  <a:srgbClr val="231F20"/>
+                </a:solidFill>
+                <a:latin typeface="Proxima Nova"/>
+              </a:rPr>
+              <a:t>• k ≥ 4, sistema do artigo: 4,5 a 5,2 pontos abaixo, com pouca variação entre seeds</a:t>
+            </a:r>
+          </a:p>
+          <a:p>
+            <a:pPr>
+              <a:spcAft>
+                <a:spcPts val="800"/>
+              </a:spcAft>
+            </a:pPr>
+            <a:r>
+              <a:rPr sz="1600" b="0">
+                <a:solidFill>
+                  <a:srgbClr val="231F20"/>
+                </a:solidFill>
+                <a:latin typeface="Proxima Nova"/>
+              </a:rPr>
+              <a:t>• k ≥ 4, M1M2: abaixo de 90% em duas seeds (k = 4) ou três (k = 8 e 16)</a:t>
+            </a:r>
+          </a:p>
+          <a:p>
+            <a:pPr>
+              <a:spcAft>
+                <a:spcPts val="800"/>
+              </a:spcAft>
+            </a:pPr>
+            <a:r>
+              <a:rPr sz="1600" b="0">
+                <a:solidFill>
+                  <a:srgbClr val="231F20"/>
+                </a:solidFill>
+                <a:latin typeface="Proxima Nova"/>
+              </a:rPr>
+              <a:t>• Não ordena os modelos em robustez</a:t>
+            </a:r>
+          </a:p>
+        </p:txBody>
+      </p:sp>
     </p:spTree>
   </p:cSld>
   <p:clrMapOvr>
@@ -8299,7 +8207,7 @@
                 </a:solidFill>
                 <a:latin typeface="Proxima Nova"/>
               </a:rPr>
-              <a:t>• A reprodução depende de um ponto que o artigo deixa em aberto</a:t>
+              <a:t>• A reprodução depende de um ponto em aberto; a Tabela II e o resumo do artigo não foram reproduzidos</a:t>
             </a:r>
           </a:p>
           <a:p>
@@ -8315,23 +8223,7 @@
                 </a:solidFill>
                 <a:latin typeface="Proxima Nova"/>
               </a:rPr>
-              <a:t>• A Tabela II e o resumo do artigo não foram reproduzidos por nenhuma leitura</a:t>
-            </a:r>
-          </a:p>
-          <a:p>
-            <a:pPr>
-              <a:spcAft>
-                <a:spcPts val="800"/>
-              </a:spcAft>
-            </a:pPr>
-            <a:r>
-              <a:rPr sz="1700" b="0">
-                <a:solidFill>
-                  <a:srgbClr val="231F20"/>
-                </a:solidFill>
-                <a:latin typeface="Proxima Nova"/>
-              </a:rPr>
-              <a:t>• O sistema não generaliza para ferramentas fora do treino</a:t>
+              <a:t>• O sistema não detectou as três ferramentas do HKD, de outra captura: recall de 1,81%</a:t>
             </a:r>
           </a:p>
           <a:p>
@@ -8363,7 +8255,7 @@
                 </a:solidFill>
                 <a:latin typeface="Proxima Nova"/>
               </a:rPr>
-              <a:t>• Um Random Forest único com peso de classe supera o empilhamento em F1 macro</a:t>
+              <a:t>• Um Random Forest único com peso de classe supera o empilhamento em F1 macro, por 0,5 ponto</a:t>
             </a:r>
           </a:p>
           <a:p>
@@ -8379,23 +8271,7 @@
                 </a:solidFill>
                 <a:latin typeface="Proxima Nova"/>
               </a:rPr>
-              <a:t>• Nossa parte: reprodução com uma seed; fragmentação só simulada</a:t>
-            </a:r>
-          </a:p>
-          <a:p>
-            <a:pPr>
-              <a:spcAft>
-                <a:spcPts val="800"/>
-              </a:spcAft>
-            </a:pPr>
-            <a:r>
-              <a:rPr sz="1700" b="0">
-                <a:solidFill>
-                  <a:srgbClr val="231F20"/>
-                </a:solidFill>
-                <a:latin typeface="Proxima Nova"/>
-              </a:rPr>
-              <a:t>• Próximo passo: gerar tráfego fragmentado e testar ferramenta deixada de fora</a:t>
+              <a:t>• Nossa parte: reprodução com uma seed; fragmentação só simulada; a modificação treina em mais tempo</a:t>
             </a:r>
           </a:p>
         </p:txBody>
@@ -8709,23 +8585,7 @@
                 </a:solidFill>
                 <a:latin typeface="Proxima Nova"/>
               </a:rPr>
-              <a:t>• O IDS só tem estatísticas de fluxo: 29 atributos, sem decifrar o TLS</a:t>
-            </a:r>
-          </a:p>
-          <a:p>
-            <a:pPr>
-              <a:spcAft>
-                <a:spcPts val="800"/>
-              </a:spcAft>
-            </a:pPr>
-            <a:r>
-              <a:rPr sz="1700" b="0">
-                <a:solidFill>
-                  <a:srgbClr val="231F20"/>
-                </a:solidFill>
-                <a:latin typeface="Proxima Nova"/>
-              </a:rPr>
-              <a:t>• Três classes: Non-DoH, Benign-DoH, Malicious-DoH</a:t>
+              <a:t>• O IDS só tem estatísticas de fluxo (29 atributos) e três classes: Non-DoH, Benign-DoH, Malicious-DoH</a:t>
             </a:r>
           </a:p>
           <a:p>
@@ -8774,6 +8634,45 @@
                 <a:latin typeface="Proxima Nova"/>
               </a:rPr>
               <a:t>• Publicado: precisão, recall e F1 acima de 99,9%</a:t>
+            </a:r>
+          </a:p>
+        </p:txBody>
+      </p:sp>
+      <p:sp>
+        <p:nvSpPr>
+          <p:cNvPr id="5" name="TextBox 4"/>
+          <p:cNvSpPr txBox="1"/>
+          <p:nvPr/>
+        </p:nvSpPr>
+        <p:spPr>
+          <a:xfrm>
+            <a:off x="311700" y="4560000"/>
+            <a:ext cx="8520600" cy="483500"/>
+          </a:xfrm>
+          <a:prstGeom prst="rect">
+            <a:avLst/>
+          </a:prstGeom>
+          <a:noFill/>
+        </p:spPr>
+        <p:txBody>
+          <a:bodyPr wrap="square">
+            <a:spAutoFit/>
+          </a:bodyPr>
+          <a:lstStyle/>
+          <a:p>
+            <a:pPr>
+              <a:spcAft>
+                <a:spcPts val="0"/>
+              </a:spcAft>
+            </a:pPr>
+            <a:r>
+              <a:rPr sz="1000" b="0">
+                <a:solidFill>
+                  <a:srgbClr val="231F20"/>
+                </a:solidFill>
+                <a:latin typeface="Proxima Nova"/>
+              </a:rPr>
+              <a:t>T. Zebin, S. Rezvy and Y. Luo, "An Explainable AI-Based Intrusion Detection System for DNS Over HTTPS (DoH) Attacks," IEEE Trans. Inf. Forensics Security, vol. 17, pp. 2339-2349, 2022, doi: 10.1109/TIFS.2022.3183390.</a:t>
             </a:r>
           </a:p>
         </p:txBody>
@@ -8958,7 +8857,7 @@
                 </a:solidFill>
                 <a:latin typeface="Proxima Nova"/>
               </a:rPr>
-              <a:t>• Segundo dataset: CIRA + HKD, com três ferramentas de túnel novas</a:t>
+              <a:t>• Segundo conjunto de dados: CIRA + DoH-Tunnel-Traffic-HKD (HKD, Mitsuhashi et al.), com três ferramentas de túnel novas</a:t>
             </a:r>
           </a:p>
           <a:p>
@@ -8974,39 +8873,7 @@
                 </a:solidFill>
                 <a:latin typeface="Proxima Nova"/>
               </a:rPr>
-              <a:t>• Protocolo corrigido: 10 seeds, teste sem vetores repetidos, folds por máquina</a:t>
-            </a:r>
-          </a:p>
-          <a:p>
-            <a:pPr>
-              <a:spcAft>
-                <a:spcPts val="800"/>
-              </a:spcAft>
-            </a:pPr>
-            <a:r>
-              <a:rPr sz="1700" b="0">
-                <a:solidFill>
-                  <a:srgbClr val="231F20"/>
-                </a:solidFill>
-                <a:latin typeface="Proxima Nova"/>
-              </a:rPr>
-              <a:t>• Modificação do sistema e teste de robustez</a:t>
-            </a:r>
-          </a:p>
-          <a:p>
-            <a:pPr>
-              <a:spcAft>
-                <a:spcPts val="800"/>
-              </a:spcAft>
-            </a:pPr>
-            <a:r>
-              <a:rPr sz="1700" b="0">
-                <a:solidFill>
-                  <a:srgbClr val="231F20"/>
-                </a:solidFill>
-                <a:latin typeface="Proxima Nova"/>
-              </a:rPr>
-              <a:t>• Um script por experimento; resultado gravado com seed, versões e commit</a:t>
+              <a:t>• Protocolo corrigido (10 seeds), modificação do sistema e teste de robustez</a:t>
             </a:r>
           </a:p>
         </p:txBody>
@@ -9109,120 +8976,17 @@
           </a:p>
         </p:txBody>
       </p:sp>
-      <p:sp>
-        <p:nvSpPr>
-          <p:cNvPr id="4" name="TextBox 3"/>
-          <p:cNvSpPr txBox="1"/>
-          <p:nvPr/>
-        </p:nvSpPr>
-        <p:spPr>
-          <a:xfrm>
-            <a:off x="311700" y="1010000"/>
-            <a:ext cx="4000000" cy="3900000"/>
-          </a:xfrm>
-          <a:prstGeom prst="rect">
-            <a:avLst/>
-          </a:prstGeom>
-          <a:noFill/>
-        </p:spPr>
-        <p:txBody>
-          <a:bodyPr wrap="square">
-            <a:spAutoFit/>
-          </a:bodyPr>
-          <a:lstStyle/>
-          <a:p>
-            <a:pPr>
-              <a:spcAft>
-                <a:spcPts val="800"/>
-              </a:spcAft>
-            </a:pPr>
-            <a:r>
-              <a:rPr sz="1600" b="0">
-                <a:solidFill>
-                  <a:srgbClr val="231F20"/>
-                </a:solidFill>
-                <a:latin typeface="Proxima Nova"/>
-              </a:rPr>
-              <a:t>• Remover linhas com valor ausente reproduz a Tabela I do artigo</a:t>
-            </a:r>
-          </a:p>
-          <a:p>
-            <a:pPr>
-              <a:spcAft>
-                <a:spcPts val="800"/>
-              </a:spcAft>
-            </a:pPr>
-            <a:r>
-              <a:rPr sz="1600" b="0">
-                <a:solidFill>
-                  <a:srgbClr val="231F20"/>
-                </a:solidFill>
-                <a:latin typeface="Proxima Nova"/>
-              </a:rPr>
-              <a:t>• Split 90/10 estratificado, seed 42</a:t>
-            </a:r>
-          </a:p>
-          <a:p>
-            <a:pPr>
-              <a:spcAft>
-                <a:spcPts val="800"/>
-              </a:spcAft>
-            </a:pPr>
-            <a:r>
-              <a:rPr sz="1600" b="0">
-                <a:solidFill>
-                  <a:srgbClr val="231F20"/>
-                </a:solidFill>
-                <a:latin typeface="Proxima Nova"/>
-              </a:rPr>
-              <a:t>• Validação cruzada de 10 folds dentro do treino</a:t>
-            </a:r>
-          </a:p>
-          <a:p>
-            <a:pPr>
-              <a:spcAft>
-                <a:spcPts val="800"/>
-              </a:spcAft>
-            </a:pPr>
-            <a:r>
-              <a:rPr sz="1600" b="0">
-                <a:solidFill>
-                  <a:srgbClr val="231F20"/>
-                </a:solidFill>
-                <a:latin typeface="Proxima Nova"/>
-              </a:rPr>
-              <a:t>• Segundo dataset: só a classe maliciosa ganha tráfego novo</a:t>
-            </a:r>
-          </a:p>
-          <a:p>
-            <a:pPr>
-              <a:spcAft>
-                <a:spcPts val="800"/>
-              </a:spcAft>
-            </a:pPr>
-            <a:r>
-              <a:rPr sz="1600" b="0">
-                <a:solidFill>
-                  <a:srgbClr val="231F20"/>
-                </a:solidFill>
-                <a:latin typeface="Proxima Nova"/>
-              </a:rPr>
-              <a:t>• No CIRA, o malicioso vem de outras máquinas e de outro período</a:t>
-            </a:r>
-          </a:p>
-        </p:txBody>
-      </p:sp>
       <p:graphicFrame>
         <p:nvGraphicFramePr>
-          <p:cNvPr id="5" name="Table 4"/>
+          <p:cNvPr id="4" name="Table 3"/>
           <p:cNvGraphicFramePr>
             <a:graphicFrameLocks noGrp="1"/>
           </p:cNvGraphicFramePr>
           <p:nvPr/>
         </p:nvGraphicFramePr>
         <p:xfrm>
-          <a:off x="4500000" y="1010000"/>
-          <a:ext cx="4029037" cy="2640000"/>
+          <a:off x="311700" y="1010000"/>
+          <a:ext cx="7924158" cy="2100000"/>
         </p:xfrm>
         <a:graphic>
           <a:graphicData uri="http://schemas.openxmlformats.org/drawingml/2006/table">
@@ -9231,12 +8995,12 @@
                 <a:tableStyleId>{5C22544A-7EE6-4342-B048-85BDC9FD1C3A}</a:tableStyleId>
               </a:tblPr>
               <a:tblGrid>
-                <a:gridCol w="1369873"/>
-                <a:gridCol w="886388"/>
-                <a:gridCol w="886388"/>
-                <a:gridCol w="886388"/>
+                <a:gridCol w="2694213"/>
+                <a:gridCol w="1743315"/>
+                <a:gridCol w="1743315"/>
+                <a:gridCol w="1743315"/>
               </a:tblGrid>
-              <a:tr h="330000">
+              <a:tr h="300000">
                 <a:tc>
                   <a:txBody>
                     <a:bodyPr wrap="square"/>
@@ -9248,13 +9012,13 @@
                         </a:spcAft>
                       </a:pPr>
                       <a:r>
-                        <a:rPr sz="1100" b="1">
+                        <a:rPr sz="1400" b="1">
                           <a:solidFill>
                             <a:srgbClr val="FFFFFF"/>
                           </a:solidFill>
                           <a:latin typeface="Proxima Nova"/>
                         </a:rPr>
-                        <a:t>Conjunto</a:t>
+                        <a:t>Fluxos por classe</a:t>
                       </a:r>
                     </a:p>
                   </a:txBody>
@@ -9275,7 +9039,7 @@
                         </a:spcAft>
                       </a:pPr>
                       <a:r>
-                        <a:rPr sz="1100" b="1">
+                        <a:rPr sz="1400" b="1">
                           <a:solidFill>
                             <a:srgbClr val="FFFFFF"/>
                           </a:solidFill>
@@ -9302,7 +9066,7 @@
                         </a:spcAft>
                       </a:pPr>
                       <a:r>
-                        <a:rPr sz="1100" b="1">
+                        <a:rPr sz="1400" b="1">
                           <a:solidFill>
                             <a:srgbClr val="FFFFFF"/>
                           </a:solidFill>
@@ -9329,7 +9093,7 @@
                         </a:spcAft>
                       </a:pPr>
                       <a:r>
-                        <a:rPr sz="1100" b="1">
+                        <a:rPr sz="1400" b="1">
                           <a:solidFill>
                             <a:srgbClr val="FFFFFF"/>
                           </a:solidFill>
@@ -9346,7 +9110,7 @@
                   </a:tcPr>
                 </a:tc>
               </a:tr>
-              <a:tr h="330000">
+              <a:tr h="300000">
                 <a:tc>
                   <a:txBody>
                     <a:bodyPr wrap="square"/>
@@ -9358,13 +9122,13 @@
                         </a:spcAft>
                       </a:pPr>
                       <a:r>
-                        <a:rPr sz="1100" b="0">
+                        <a:rPr sz="1400" b="0">
                           <a:solidFill>
                             <a:srgbClr val="231F20"/>
                           </a:solidFill>
                           <a:latin typeface="Proxima Nova"/>
                         </a:rPr>
-                        <a:t>CIRA limpo</a:t>
+                        <a:t>CIRA limpo (igual à Tabela I)</a:t>
                       </a:r>
                     </a:p>
                   </a:txBody>
@@ -9385,7 +9149,7 @@
                         </a:spcAft>
                       </a:pPr>
                       <a:r>
-                        <a:rPr sz="1100" b="0">
+                        <a:rPr sz="1400" b="0">
                           <a:solidFill>
                             <a:srgbClr val="231F20"/>
                           </a:solidFill>
@@ -9412,7 +9176,7 @@
                         </a:spcAft>
                       </a:pPr>
                       <a:r>
-                        <a:rPr sz="1100" b="0">
+                        <a:rPr sz="1400" b="0">
                           <a:solidFill>
                             <a:srgbClr val="231F20"/>
                           </a:solidFill>
@@ -9439,7 +9203,7 @@
                         </a:spcAft>
                       </a:pPr>
                       <a:r>
-                        <a:rPr sz="1100" b="0">
+                        <a:rPr sz="1400" b="0">
                           <a:solidFill>
                             <a:srgbClr val="231F20"/>
                           </a:solidFill>
@@ -9456,7 +9220,7 @@
                   </a:tcPr>
                 </a:tc>
               </a:tr>
-              <a:tr h="330000">
+              <a:tr h="300000">
                 <a:tc>
                   <a:txBody>
                     <a:bodyPr wrap="square"/>
@@ -9468,13 +9232,13 @@
                         </a:spcAft>
                       </a:pPr>
                       <a:r>
-                        <a:rPr sz="1100" b="0">
+                        <a:rPr sz="1400" b="0">
                           <a:solidFill>
                             <a:srgbClr val="231F20"/>
                           </a:solidFill>
                           <a:latin typeface="Proxima Nova"/>
                         </a:rPr>
-                        <a:t>Tabela I do artigo</a:t>
+                        <a:t>CIRA: treino</a:t>
                       </a:r>
                     </a:p>
                   </a:txBody>
@@ -9495,13 +9259,13 @@
                         </a:spcAft>
                       </a:pPr>
                       <a:r>
-                        <a:rPr sz="1100" b="0">
+                        <a:rPr sz="1400" b="0">
                           <a:solidFill>
                             <a:srgbClr val="231F20"/>
                           </a:solidFill>
                           <a:latin typeface="Proxima Nova"/>
                         </a:rPr>
-                        <a:t>889809</a:t>
+                        <a:t>800828</a:t>
                       </a:r>
                     </a:p>
                   </a:txBody>
@@ -9522,13 +9286,13 @@
                         </a:spcAft>
                       </a:pPr>
                       <a:r>
-                        <a:rPr sz="1100" b="0">
+                        <a:rPr sz="1400" b="0">
                           <a:solidFill>
                             <a:srgbClr val="231F20"/>
                           </a:solidFill>
                           <a:latin typeface="Proxima Nova"/>
                         </a:rPr>
-                        <a:t>19746</a:t>
+                        <a:t>17771</a:t>
                       </a:r>
                     </a:p>
                   </a:txBody>
@@ -9549,13 +9313,13 @@
                         </a:spcAft>
                       </a:pPr>
                       <a:r>
-                        <a:rPr sz="1100" b="0">
+                        <a:rPr sz="1400" b="0">
                           <a:solidFill>
                             <a:srgbClr val="231F20"/>
                           </a:solidFill>
                           <a:latin typeface="Proxima Nova"/>
                         </a:rPr>
-                        <a:t>249553</a:t>
+                        <a:t>224598</a:t>
                       </a:r>
                     </a:p>
                   </a:txBody>
@@ -9566,7 +9330,7 @@
                   </a:tcPr>
                 </a:tc>
               </a:tr>
-              <a:tr h="330000">
+              <a:tr h="300000">
                 <a:tc>
                   <a:txBody>
                     <a:bodyPr wrap="square"/>
@@ -9578,13 +9342,13 @@
                         </a:spcAft>
                       </a:pPr>
                       <a:r>
-                        <a:rPr sz="1100" b="0">
+                        <a:rPr sz="1400" b="0">
                           <a:solidFill>
                             <a:srgbClr val="231F20"/>
                           </a:solidFill>
                           <a:latin typeface="Proxima Nova"/>
                         </a:rPr>
-                        <a:t>CIRA: treino</a:t>
+                        <a:t>CIRA: teste</a:t>
                       </a:r>
                     </a:p>
                   </a:txBody>
@@ -9605,13 +9369,13 @@
                         </a:spcAft>
                       </a:pPr>
                       <a:r>
-                        <a:rPr sz="1100" b="0">
+                        <a:rPr sz="1400" b="0">
                           <a:solidFill>
                             <a:srgbClr val="231F20"/>
                           </a:solidFill>
                           <a:latin typeface="Proxima Nova"/>
                         </a:rPr>
-                        <a:t>800828</a:t>
+                        <a:t>88981</a:t>
                       </a:r>
                     </a:p>
                   </a:txBody>
@@ -9632,13 +9396,13 @@
                         </a:spcAft>
                       </a:pPr>
                       <a:r>
-                        <a:rPr sz="1100" b="0">
+                        <a:rPr sz="1400" b="0">
                           <a:solidFill>
                             <a:srgbClr val="231F20"/>
                           </a:solidFill>
                           <a:latin typeface="Proxima Nova"/>
                         </a:rPr>
-                        <a:t>17771</a:t>
+                        <a:t>1975</a:t>
                       </a:r>
                     </a:p>
                   </a:txBody>
@@ -9659,13 +9423,13 @@
                         </a:spcAft>
                       </a:pPr>
                       <a:r>
-                        <a:rPr sz="1100" b="0">
+                        <a:rPr sz="1400" b="0">
                           <a:solidFill>
                             <a:srgbClr val="231F20"/>
                           </a:solidFill>
                           <a:latin typeface="Proxima Nova"/>
                         </a:rPr>
-                        <a:t>224598</a:t>
+                        <a:t>24955</a:t>
                       </a:r>
                     </a:p>
                   </a:txBody>
@@ -9676,7 +9440,7 @@
                   </a:tcPr>
                 </a:tc>
               </a:tr>
-              <a:tr h="330000">
+              <a:tr h="300000">
                 <a:tc>
                   <a:txBody>
                     <a:bodyPr wrap="square"/>
@@ -9688,13 +9452,13 @@
                         </a:spcAft>
                       </a:pPr>
                       <a:r>
-                        <a:rPr sz="1100" b="0">
+                        <a:rPr sz="1400" b="0">
                           <a:solidFill>
                             <a:srgbClr val="231F20"/>
                           </a:solidFill>
                           <a:latin typeface="Proxima Nova"/>
                         </a:rPr>
-                        <a:t>CIRA: teste</a:t>
+                        <a:t>Combinado: treino</a:t>
                       </a:r>
                     </a:p>
                   </a:txBody>
@@ -9715,13 +9479,13 @@
                         </a:spcAft>
                       </a:pPr>
                       <a:r>
-                        <a:rPr sz="1100" b="0">
+                        <a:rPr sz="1400" b="0">
                           <a:solidFill>
                             <a:srgbClr val="231F20"/>
                           </a:solidFill>
                           <a:latin typeface="Proxima Nova"/>
                         </a:rPr>
-                        <a:t>88981</a:t>
+                        <a:t>800828</a:t>
                       </a:r>
                     </a:p>
                   </a:txBody>
@@ -9742,13 +9506,13 @@
                         </a:spcAft>
                       </a:pPr>
                       <a:r>
-                        <a:rPr sz="1100" b="0">
+                        <a:rPr sz="1400" b="0">
                           <a:solidFill>
                             <a:srgbClr val="231F20"/>
                           </a:solidFill>
                           <a:latin typeface="Proxima Nova"/>
                         </a:rPr>
-                        <a:t>1975</a:t>
+                        <a:t>17771</a:t>
                       </a:r>
                     </a:p>
                   </a:txBody>
@@ -9769,13 +9533,13 @@
                         </a:spcAft>
                       </a:pPr>
                       <a:r>
-                        <a:rPr sz="1100" b="0">
+                        <a:rPr sz="1400" b="0">
                           <a:solidFill>
                             <a:srgbClr val="231F20"/>
                           </a:solidFill>
                           <a:latin typeface="Proxima Nova"/>
                         </a:rPr>
-                        <a:t>24955</a:t>
+                        <a:t>229330</a:t>
                       </a:r>
                     </a:p>
                   </a:txBody>
@@ -9786,7 +9550,7 @@
                   </a:tcPr>
                 </a:tc>
               </a:tr>
-              <a:tr h="330000">
+              <a:tr h="300000">
                 <a:tc>
                   <a:txBody>
                     <a:bodyPr wrap="square"/>
@@ -9798,13 +9562,13 @@
                         </a:spcAft>
                       </a:pPr>
                       <a:r>
-                        <a:rPr sz="1100" b="0">
+                        <a:rPr sz="1400" b="0">
                           <a:solidFill>
                             <a:srgbClr val="231F20"/>
                           </a:solidFill>
                           <a:latin typeface="Proxima Nova"/>
                         </a:rPr>
-                        <a:t>Combinado: treino</a:t>
+                        <a:t>Combinado: teste</a:t>
                       </a:r>
                     </a:p>
                   </a:txBody>
@@ -9825,13 +9589,13 @@
                         </a:spcAft>
                       </a:pPr>
                       <a:r>
-                        <a:rPr sz="1100" b="0">
+                        <a:rPr sz="1400" b="0">
                           <a:solidFill>
                             <a:srgbClr val="231F20"/>
                           </a:solidFill>
                           <a:latin typeface="Proxima Nova"/>
                         </a:rPr>
-                        <a:t>800828</a:t>
+                        <a:t>88981</a:t>
                       </a:r>
                     </a:p>
                   </a:txBody>
@@ -9852,13 +9616,13 @@
                         </a:spcAft>
                       </a:pPr>
                       <a:r>
-                        <a:rPr sz="1100" b="0">
+                        <a:rPr sz="1400" b="0">
                           <a:solidFill>
                             <a:srgbClr val="231F20"/>
                           </a:solidFill>
                           <a:latin typeface="Proxima Nova"/>
                         </a:rPr>
-                        <a:t>17771</a:t>
+                        <a:t>1975</a:t>
                       </a:r>
                     </a:p>
                   </a:txBody>
@@ -9879,13 +9643,13 @@
                         </a:spcAft>
                       </a:pPr>
                       <a:r>
-                        <a:rPr sz="1100" b="0">
+                        <a:rPr sz="1400" b="0">
                           <a:solidFill>
                             <a:srgbClr val="231F20"/>
                           </a:solidFill>
                           <a:latin typeface="Proxima Nova"/>
                         </a:rPr>
-                        <a:t>229330</a:t>
+                        <a:t>25481</a:t>
                       </a:r>
                     </a:p>
                   </a:txBody>
@@ -9896,7 +9660,7 @@
                   </a:tcPr>
                 </a:tc>
               </a:tr>
-              <a:tr h="330000">
+              <a:tr h="300000">
                 <a:tc>
                   <a:txBody>
                     <a:bodyPr wrap="square"/>
@@ -9908,13 +9672,13 @@
                         </a:spcAft>
                       </a:pPr>
                       <a:r>
-                        <a:rPr sz="1100" b="0">
+                        <a:rPr sz="1400" b="0">
                           <a:solidFill>
                             <a:srgbClr val="231F20"/>
                           </a:solidFill>
                           <a:latin typeface="Proxima Nova"/>
                         </a:rPr>
-                        <a:t>Combinado: teste</a:t>
+                        <a:t>HKD isolado (só teste)</a:t>
                       </a:r>
                     </a:p>
                   </a:txBody>
@@ -9935,13 +9699,13 @@
                         </a:spcAft>
                       </a:pPr>
                       <a:r>
-                        <a:rPr sz="1100" b="0">
+                        <a:rPr sz="1400" b="0">
                           <a:solidFill>
                             <a:srgbClr val="231F20"/>
                           </a:solidFill>
                           <a:latin typeface="Proxima Nova"/>
                         </a:rPr>
-                        <a:t>88981</a:t>
+                        <a:t>0</a:t>
                       </a:r>
                     </a:p>
                   </a:txBody>
@@ -9962,13 +9726,13 @@
                         </a:spcAft>
                       </a:pPr>
                       <a:r>
-                        <a:rPr sz="1100" b="0">
+                        <a:rPr sz="1400" b="0">
                           <a:solidFill>
                             <a:srgbClr val="231F20"/>
                           </a:solidFill>
                           <a:latin typeface="Proxima Nova"/>
                         </a:rPr>
-                        <a:t>1975</a:t>
+                        <a:t>0</a:t>
                       </a:r>
                     </a:p>
                   </a:txBody>
@@ -9989,117 +9753,7 @@
                         </a:spcAft>
                       </a:pPr>
                       <a:r>
-                        <a:rPr sz="1100" b="0">
-                          <a:solidFill>
-                            <a:srgbClr val="231F20"/>
-                          </a:solidFill>
-                          <a:latin typeface="Proxima Nova"/>
-                        </a:rPr>
-                        <a:t>25481</a:t>
-                      </a:r>
-                    </a:p>
-                  </a:txBody>
-                  <a:tcPr marT="30000" marB="30000">
-                    <a:solidFill>
-                      <a:srgbClr val="EEEEEE"/>
-                    </a:solidFill>
-                  </a:tcPr>
-                </a:tc>
-              </a:tr>
-              <a:tr h="330000">
-                <a:tc>
-                  <a:txBody>
-                    <a:bodyPr wrap="square"/>
-                    <a:lstStyle/>
-                    <a:p>
-                      <a:pPr>
-                        <a:spcAft>
-                          <a:spcPts val="0"/>
-                        </a:spcAft>
-                      </a:pPr>
-                      <a:r>
-                        <a:rPr sz="1100" b="0">
-                          <a:solidFill>
-                            <a:srgbClr val="231F20"/>
-                          </a:solidFill>
-                          <a:latin typeface="Proxima Nova"/>
-                        </a:rPr>
-                        <a:t>HKD isolado</a:t>
-                      </a:r>
-                    </a:p>
-                  </a:txBody>
-                  <a:tcPr marT="30000" marB="30000">
-                    <a:solidFill>
-                      <a:srgbClr val="FFFFFF"/>
-                    </a:solidFill>
-                  </a:tcPr>
-                </a:tc>
-                <a:tc>
-                  <a:txBody>
-                    <a:bodyPr wrap="square"/>
-                    <a:lstStyle/>
-                    <a:p>
-                      <a:pPr>
-                        <a:spcAft>
-                          <a:spcPts val="0"/>
-                        </a:spcAft>
-                      </a:pPr>
-                      <a:r>
-                        <a:rPr sz="1100" b="0">
-                          <a:solidFill>
-                            <a:srgbClr val="231F20"/>
-                          </a:solidFill>
-                          <a:latin typeface="Proxima Nova"/>
-                        </a:rPr>
-                        <a:t>0</a:t>
-                      </a:r>
-                    </a:p>
-                  </a:txBody>
-                  <a:tcPr marT="30000" marB="30000">
-                    <a:solidFill>
-                      <a:srgbClr val="FFFFFF"/>
-                    </a:solidFill>
-                  </a:tcPr>
-                </a:tc>
-                <a:tc>
-                  <a:txBody>
-                    <a:bodyPr wrap="square"/>
-                    <a:lstStyle/>
-                    <a:p>
-                      <a:pPr>
-                        <a:spcAft>
-                          <a:spcPts val="0"/>
-                        </a:spcAft>
-                      </a:pPr>
-                      <a:r>
-                        <a:rPr sz="1100" b="0">
-                          <a:solidFill>
-                            <a:srgbClr val="231F20"/>
-                          </a:solidFill>
-                          <a:latin typeface="Proxima Nova"/>
-                        </a:rPr>
-                        <a:t>0</a:t>
-                      </a:r>
-                    </a:p>
-                  </a:txBody>
-                  <a:tcPr marT="30000" marB="30000">
-                    <a:solidFill>
-                      <a:srgbClr val="FFFFFF"/>
-                    </a:solidFill>
-                  </a:tcPr>
-                </a:tc>
-                <a:tc>
-                  <a:txBody>
-                    <a:bodyPr wrap="square"/>
-                    <a:lstStyle/>
-                    <a:p>
-                      <a:pPr>
-                        <a:spcAft>
-                          <a:spcPts val="0"/>
-                        </a:spcAft>
-                      </a:pPr>
-                      <a:r>
-                        <a:rPr sz="1100" b="0">
+                        <a:rPr sz="1400" b="0">
                           <a:solidFill>
                             <a:srgbClr val="231F20"/>
                           </a:solidFill>
@@ -10111,7 +9765,7 @@
                   </a:txBody>
                   <a:tcPr marT="30000" marB="30000">
                     <a:solidFill>
-                      <a:srgbClr val="FFFFFF"/>
+                      <a:srgbClr val="EEEEEE"/>
                     </a:solidFill>
                   </a:tcPr>
                 </a:tc>
@@ -10120,6 +9774,93 @@
           </a:graphicData>
         </a:graphic>
       </p:graphicFrame>
+      <p:sp>
+        <p:nvSpPr>
+          <p:cNvPr id="5" name="TextBox 4"/>
+          <p:cNvSpPr txBox="1"/>
+          <p:nvPr/>
+        </p:nvSpPr>
+        <p:spPr>
+          <a:xfrm>
+            <a:off x="311700" y="3210000"/>
+            <a:ext cx="8520600" cy="1783500"/>
+          </a:xfrm>
+          <a:prstGeom prst="rect">
+            <a:avLst/>
+          </a:prstGeom>
+          <a:noFill/>
+        </p:spPr>
+        <p:txBody>
+          <a:bodyPr wrap="square">
+            <a:spAutoFit/>
+          </a:bodyPr>
+          <a:lstStyle/>
+          <a:p>
+            <a:pPr>
+              <a:spcAft>
+                <a:spcPts val="800"/>
+              </a:spcAft>
+            </a:pPr>
+            <a:r>
+              <a:rPr sz="1600" b="0">
+                <a:solidFill>
+                  <a:srgbClr val="231F20"/>
+                </a:solidFill>
+                <a:latin typeface="Proxima Nova"/>
+              </a:rPr>
+              <a:t>• Remover fluxos com valor ausente reproduz a Tabela I do artigo</a:t>
+            </a:r>
+          </a:p>
+          <a:p>
+            <a:pPr>
+              <a:spcAft>
+                <a:spcPts val="800"/>
+              </a:spcAft>
+            </a:pPr>
+            <a:r>
+              <a:rPr sz="1600" b="0">
+                <a:solidFill>
+                  <a:srgbClr val="231F20"/>
+                </a:solidFill>
+                <a:latin typeface="Proxima Nova"/>
+              </a:rPr>
+              <a:t>• Split 90/10 estratificado, seed 42; validação cruzada de 10 folds no treino</a:t>
+            </a:r>
+          </a:p>
+          <a:p>
+            <a:pPr>
+              <a:spcAft>
+                <a:spcPts val="800"/>
+              </a:spcAft>
+            </a:pPr>
+            <a:r>
+              <a:rPr sz="1600" b="0">
+                <a:solidFill>
+                  <a:srgbClr val="231F20"/>
+                </a:solidFill>
+                <a:latin typeface="Proxima Nova"/>
+              </a:rPr>
+              <a:t>• Segundo conjunto (combinado sem réplicas): só a classe maliciosa ganha tráfego novo</a:t>
+            </a:r>
+          </a:p>
+          <a:p>
+            <a:pPr>
+              <a:spcAft>
+                <a:spcPts val="800"/>
+              </a:spcAft>
+            </a:pPr>
+            <a:r>
+              <a:rPr sz="1600" b="0">
+                <a:solidFill>
+                  <a:srgbClr val="231F20"/>
+                </a:solidFill>
+                <a:latin typeface="Proxima Nova"/>
+              </a:rPr>
+              <a:t>• No CIRA, o malicioso vem de outras máquinas e de outro período</a:t>
+            </a:r>
+          </a:p>
+        </p:txBody>
+      </p:sp>
     </p:spTree>
   </p:cSld>
   <p:clrMapOvr>
@@ -10218,80 +9959,9 @@
           </a:p>
         </p:txBody>
       </p:sp>
-      <p:sp>
-        <p:nvSpPr>
-          <p:cNvPr id="4" name="TextBox 3"/>
-          <p:cNvSpPr txBox="1"/>
-          <p:nvPr/>
-        </p:nvSpPr>
-        <p:spPr>
-          <a:xfrm>
-            <a:off x="311700" y="3590000"/>
-            <a:ext cx="8520600" cy="1403500"/>
-          </a:xfrm>
-          <a:prstGeom prst="rect">
-            <a:avLst/>
-          </a:prstGeom>
-          <a:noFill/>
-        </p:spPr>
-        <p:txBody>
-          <a:bodyPr wrap="square">
-            <a:spAutoFit/>
-          </a:bodyPr>
-          <a:lstStyle/>
-          <a:p>
-            <a:pPr>
-              <a:spcAft>
-                <a:spcPts val="800"/>
-              </a:spcAft>
-            </a:pPr>
-            <a:r>
-              <a:rPr sz="1600" b="0">
-                <a:solidFill>
-                  <a:srgbClr val="231F20"/>
-                </a:solidFill>
-                <a:latin typeface="Proxima Nova"/>
-              </a:rPr>
-              <a:t>• Profundidade 5: nenhum Benign-DoH predito, e a acurácia ainda é 97,79%</a:t>
-            </a:r>
-          </a:p>
-          <a:p>
-            <a:pPr>
-              <a:spcAft>
-                <a:spcPts val="800"/>
-              </a:spcAft>
-            </a:pPr>
-            <a:r>
-              <a:rPr sz="1600" b="0">
-                <a:solidFill>
-                  <a:srgbClr val="231F20"/>
-                </a:solidFill>
-                <a:latin typeface="Proxima Nova"/>
-              </a:rPr>
-              <a:t>• Profundidade variável: a 553 fluxos da matriz do artigo, contra 4711</a:t>
-            </a:r>
-          </a:p>
-          <a:p>
-            <a:pPr>
-              <a:spcAft>
-                <a:spcPts val="800"/>
-              </a:spcAft>
-            </a:pPr>
-            <a:r>
-              <a:rPr sz="1600" b="0">
-                <a:solidFill>
-                  <a:srgbClr val="231F20"/>
-                </a:solidFill>
-                <a:latin typeface="Proxima Nova"/>
-              </a:rPr>
-              <a:t>• A proximidade não diz qual configuração os autores usaram</a:t>
-            </a:r>
-          </a:p>
-        </p:txBody>
-      </p:sp>
       <p:pic>
         <p:nvPicPr>
-          <p:cNvPr id="5" name="Picture 4" descr="matriz_confusao_teste_dupla.png"/>
+          <p:cNvPr id="4" name="Picture 3" descr="matriz_confusao_teste_dupla.png"/>
           <p:cNvPicPr>
             <a:picLocks noChangeAspect="1"/>
           </p:cNvPicPr>
@@ -10313,6 +9983,77 @@
           </a:prstGeom>
         </p:spPr>
       </p:pic>
+      <p:sp>
+        <p:nvSpPr>
+          <p:cNvPr id="5" name="TextBox 4"/>
+          <p:cNvSpPr txBox="1"/>
+          <p:nvPr/>
+        </p:nvSpPr>
+        <p:spPr>
+          <a:xfrm>
+            <a:off x="311700" y="3610000"/>
+            <a:ext cx="8520600" cy="1383500"/>
+          </a:xfrm>
+          <a:prstGeom prst="rect">
+            <a:avLst/>
+          </a:prstGeom>
+          <a:noFill/>
+        </p:spPr>
+        <p:txBody>
+          <a:bodyPr wrap="square">
+            <a:spAutoFit/>
+          </a:bodyPr>
+          <a:lstStyle/>
+          <a:p>
+            <a:pPr>
+              <a:spcAft>
+                <a:spcPts val="800"/>
+              </a:spcAft>
+            </a:pPr>
+            <a:r>
+              <a:rPr sz="1600" b="0">
+                <a:solidFill>
+                  <a:srgbClr val="231F20"/>
+                </a:solidFill>
+                <a:latin typeface="Proxima Nova"/>
+              </a:rPr>
+              <a:t>• Profundidade 5: nenhum Benign-DoH predito, e a acurácia ainda é 97,79%</a:t>
+            </a:r>
+          </a:p>
+          <a:p>
+            <a:pPr>
+              <a:spcAft>
+                <a:spcPts val="800"/>
+              </a:spcAft>
+            </a:pPr>
+            <a:r>
+              <a:rPr sz="1600" b="0">
+                <a:solidFill>
+                  <a:srgbClr val="231F20"/>
+                </a:solidFill>
+                <a:latin typeface="Proxima Nova"/>
+              </a:rPr>
+              <a:t>• Profundidade variável: a 553 fluxos da matriz do artigo, contra 4711</a:t>
+            </a:r>
+          </a:p>
+          <a:p>
+            <a:pPr>
+              <a:spcAft>
+                <a:spcPts val="800"/>
+              </a:spcAft>
+            </a:pPr>
+            <a:r>
+              <a:rPr sz="1600" b="0">
+                <a:solidFill>
+                  <a:srgbClr val="231F20"/>
+                </a:solidFill>
+                <a:latin typeface="Proxima Nova"/>
+              </a:rPr>
+              <a:t>• A proximidade não diz qual configuração os autores usaram</a:t>
+            </a:r>
+          </a:p>
+        </p:txBody>
+      </p:sp>
     </p:spTree>
   </p:cSld>
   <p:clrMapOvr>
@@ -10411,104 +10152,17 @@
           </a:p>
         </p:txBody>
       </p:sp>
-      <p:sp>
-        <p:nvSpPr>
-          <p:cNvPr id="4" name="TextBox 3"/>
-          <p:cNvSpPr txBox="1"/>
-          <p:nvPr/>
-        </p:nvSpPr>
-        <p:spPr>
-          <a:xfrm>
-            <a:off x="311700" y="1010000"/>
-            <a:ext cx="4000000" cy="3900000"/>
-          </a:xfrm>
-          <a:prstGeom prst="rect">
-            <a:avLst/>
-          </a:prstGeom>
-          <a:noFill/>
-        </p:spPr>
-        <p:txBody>
-          <a:bodyPr wrap="square">
-            <a:spAutoFit/>
-          </a:bodyPr>
-          <a:lstStyle/>
-          <a:p>
-            <a:pPr>
-              <a:spcAft>
-                <a:spcPts val="800"/>
-              </a:spcAft>
-            </a:pPr>
-            <a:r>
-              <a:rPr sz="1600" b="0">
-                <a:solidFill>
-                  <a:srgbClr val="231F20"/>
-                </a:solidFill>
-                <a:latin typeface="Proxima Nova"/>
-              </a:rPr>
-              <a:t>• Sozinhos, os três Random Forests acertam 85% a 86% do Benign-DoH</a:t>
-            </a:r>
-          </a:p>
-          <a:p>
-            <a:pPr>
-              <a:spcAft>
-                <a:spcPts val="800"/>
-              </a:spcAft>
-            </a:pPr>
-            <a:r>
-              <a:rPr sz="1600" b="0">
-                <a:solidFill>
-                  <a:srgbClr val="231F20"/>
-                </a:solidFill>
-                <a:latin typeface="Proxima Nova"/>
-              </a:rPr>
-              <a:t>• A perda acontece na regressão logística que os combina</a:t>
-            </a:r>
-          </a:p>
-          <a:p>
-            <a:pPr>
-              <a:spcAft>
-                <a:spcPts val="800"/>
-              </a:spcAft>
-            </a:pPr>
-            <a:r>
-              <a:rPr sz="1600" b="0">
-                <a:solidFill>
-                  <a:srgbClr val="231F20"/>
-                </a:solidFill>
-                <a:latin typeface="Proxima Nova"/>
-              </a:rPr>
-              <a:t>• No treino, quando os três dizem Benign-DoH, a classe real mais comum é Non-DoH</a:t>
-            </a:r>
-          </a:p>
-          <a:p>
-            <a:pPr>
-              <a:spcAft>
-                <a:spcPts val="800"/>
-              </a:spcAft>
-            </a:pPr>
-            <a:r>
-              <a:rPr sz="1600" b="0">
-                <a:solidFill>
-                  <a:srgbClr val="231F20"/>
-                </a:solidFill>
-                <a:latin typeface="Proxima Nova"/>
-              </a:rPr>
-              <a:t>• A acurácia esconde a classe rara: Benign-DoH é 1,70% do teste</a:t>
-            </a:r>
-          </a:p>
-        </p:txBody>
-      </p:sp>
       <p:graphicFrame>
         <p:nvGraphicFramePr>
-          <p:cNvPr id="5" name="Table 4"/>
+          <p:cNvPr id="4" name="Table 3"/>
           <p:cNvGraphicFramePr>
             <a:graphicFrameLocks noGrp="1"/>
           </p:cNvGraphicFramePr>
           <p:nvPr/>
         </p:nvGraphicFramePr>
         <p:xfrm>
-          <a:off x="4500000" y="1010000"/>
-          <a:ext cx="4029037" cy="1980000"/>
+          <a:off x="311700" y="1010000"/>
+          <a:ext cx="7924158" cy="1800000"/>
         </p:xfrm>
         <a:graphic>
           <a:graphicData uri="http://schemas.openxmlformats.org/drawingml/2006/table">
@@ -10517,12 +10171,12 @@
                 <a:tableStyleId>{5C22544A-7EE6-4342-B048-85BDC9FD1C3A}</a:tableStyleId>
               </a:tblPr>
               <a:tblGrid>
-                <a:gridCol w="1369873"/>
-                <a:gridCol w="886388"/>
-                <a:gridCol w="886388"/>
-                <a:gridCol w="886388"/>
+                <a:gridCol w="2694213"/>
+                <a:gridCol w="1743315"/>
+                <a:gridCol w="1743315"/>
+                <a:gridCol w="1743315"/>
               </a:tblGrid>
-              <a:tr h="330000">
+              <a:tr h="300000">
                 <a:tc>
                   <a:txBody>
                     <a:bodyPr wrap="square"/>
@@ -10534,13 +10188,13 @@
                         </a:spcAft>
                       </a:pPr>
                       <a:r>
-                        <a:rPr sz="1100" b="1">
+                        <a:rPr sz="1400" b="1">
                           <a:solidFill>
                             <a:srgbClr val="FFFFFF"/>
                           </a:solidFill>
                           <a:latin typeface="Proxima Nova"/>
                         </a:rPr>
-                        <a:t>Métrica</a:t>
+                        <a:t>Teste, em %</a:t>
                       </a:r>
                     </a:p>
                   </a:txBody>
@@ -10561,13 +10215,13 @@
                         </a:spcAft>
                       </a:pPr>
                       <a:r>
-                        <a:rPr sz="1100" b="1">
+                        <a:rPr sz="1400" b="1">
                           <a:solidFill>
                             <a:srgbClr val="FFFFFF"/>
                           </a:solidFill>
                           <a:latin typeface="Proxima Nova"/>
                         </a:rPr>
-                        <a:t>Artigo</a:t>
+                        <a:t>Artigo (Fig. 4b)</a:t>
                       </a:r>
                     </a:p>
                   </a:txBody>
@@ -10588,13 +10242,13 @@
                         </a:spcAft>
                       </a:pPr>
                       <a:r>
-                        <a:rPr sz="1100" b="1">
+                        <a:rPr sz="1400" b="1">
                           <a:solidFill>
                             <a:srgbClr val="FFFFFF"/>
                           </a:solidFill>
                           <a:latin typeface="Proxima Nova"/>
                         </a:rPr>
-                        <a:t>Prof. 5</a:t>
+                        <a:t>Profundidade 5</a:t>
                       </a:r>
                     </a:p>
                   </a:txBody>
@@ -10615,13 +10269,13 @@
                         </a:spcAft>
                       </a:pPr>
                       <a:r>
-                        <a:rPr sz="1100" b="1">
+                        <a:rPr sz="1400" b="1">
                           <a:solidFill>
                             <a:srgbClr val="FFFFFF"/>
                           </a:solidFill>
                           <a:latin typeface="Proxima Nova"/>
                         </a:rPr>
-                        <a:t>Prof. var.</a:t>
+                        <a:t>Prof. variável</a:t>
                       </a:r>
                     </a:p>
                   </a:txBody>
@@ -10632,7 +10286,7 @@
                   </a:tcPr>
                 </a:tc>
               </a:tr>
-              <a:tr h="330000">
+              <a:tr h="300000">
                 <a:tc>
                   <a:txBody>
                     <a:bodyPr wrap="square"/>
@@ -10644,7 +10298,7 @@
                         </a:spcAft>
                       </a:pPr>
                       <a:r>
-                        <a:rPr sz="1100" b="0">
+                        <a:rPr sz="1400" b="0">
                           <a:solidFill>
                             <a:srgbClr val="231F20"/>
                           </a:solidFill>
@@ -10671,7 +10325,7 @@
                         </a:spcAft>
                       </a:pPr>
                       <a:r>
-                        <a:rPr sz="1100" b="0">
+                        <a:rPr sz="1400" b="0">
                           <a:solidFill>
                             <a:srgbClr val="231F20"/>
                           </a:solidFill>
@@ -10698,7 +10352,7 @@
                         </a:spcAft>
                       </a:pPr>
                       <a:r>
-                        <a:rPr sz="1100" b="0">
+                        <a:rPr sz="1400" b="0">
                           <a:solidFill>
                             <a:srgbClr val="231F20"/>
                           </a:solidFill>
@@ -10725,7 +10379,7 @@
                         </a:spcAft>
                       </a:pPr>
                       <a:r>
-                        <a:rPr sz="1100" b="0">
+                        <a:rPr sz="1400" b="0">
                           <a:solidFill>
                             <a:srgbClr val="231F20"/>
                           </a:solidFill>
@@ -10742,7 +10396,7 @@
                   </a:tcPr>
                 </a:tc>
               </a:tr>
-              <a:tr h="330000">
+              <a:tr h="300000">
                 <a:tc>
                   <a:txBody>
                     <a:bodyPr wrap="square"/>
@@ -10754,7 +10408,7 @@
                         </a:spcAft>
                       </a:pPr>
                       <a:r>
-                        <a:rPr sz="1100" b="0">
+                        <a:rPr sz="1400" b="0">
                           <a:solidFill>
                             <a:srgbClr val="231F20"/>
                           </a:solidFill>
@@ -10781,7 +10435,7 @@
                         </a:spcAft>
                       </a:pPr>
                       <a:r>
-                        <a:rPr sz="1100" b="0">
+                        <a:rPr sz="1400" b="0">
                           <a:solidFill>
                             <a:srgbClr val="231F20"/>
                           </a:solidFill>
@@ -10808,7 +10462,7 @@
                         </a:spcAft>
                       </a:pPr>
                       <a:r>
-                        <a:rPr sz="1100" b="0">
+                        <a:rPr sz="1400" b="0">
                           <a:solidFill>
                             <a:srgbClr val="231F20"/>
                           </a:solidFill>
@@ -10835,7 +10489,7 @@
                         </a:spcAft>
                       </a:pPr>
                       <a:r>
-                        <a:rPr sz="1100" b="0">
+                        <a:rPr sz="1400" b="0">
                           <a:solidFill>
                             <a:srgbClr val="231F20"/>
                           </a:solidFill>
@@ -10852,7 +10506,7 @@
                   </a:tcPr>
                 </a:tc>
               </a:tr>
-              <a:tr h="330000">
+              <a:tr h="300000">
                 <a:tc>
                   <a:txBody>
                     <a:bodyPr wrap="square"/>
@@ -10864,7 +10518,7 @@
                         </a:spcAft>
                       </a:pPr>
                       <a:r>
-                        <a:rPr sz="1100" b="0">
+                        <a:rPr sz="1400" b="0">
                           <a:solidFill>
                             <a:srgbClr val="231F20"/>
                           </a:solidFill>
@@ -10891,7 +10545,7 @@
                         </a:spcAft>
                       </a:pPr>
                       <a:r>
-                        <a:rPr sz="1100" b="0">
+                        <a:rPr sz="1400" b="0">
                           <a:solidFill>
                             <a:srgbClr val="231F20"/>
                           </a:solidFill>
@@ -10918,7 +10572,7 @@
                         </a:spcAft>
                       </a:pPr>
                       <a:r>
-                        <a:rPr sz="1100" b="0">
+                        <a:rPr sz="1400" b="0">
                           <a:solidFill>
                             <a:srgbClr val="231F20"/>
                           </a:solidFill>
@@ -10945,7 +10599,7 @@
                         </a:spcAft>
                       </a:pPr>
                       <a:r>
-                        <a:rPr sz="1100" b="0">
+                        <a:rPr sz="1400" b="0">
                           <a:solidFill>
                             <a:srgbClr val="231F20"/>
                           </a:solidFill>
@@ -10962,7 +10616,7 @@
                   </a:tcPr>
                 </a:tc>
               </a:tr>
-              <a:tr h="330000">
+              <a:tr h="300000">
                 <a:tc>
                   <a:txBody>
                     <a:bodyPr wrap="square"/>
@@ -10974,7 +10628,7 @@
                         </a:spcAft>
                       </a:pPr>
                       <a:r>
-                        <a:rPr sz="1100" b="0">
+                        <a:rPr sz="1400" b="0">
                           <a:solidFill>
                             <a:srgbClr val="231F20"/>
                           </a:solidFill>
@@ -11001,7 +10655,7 @@
                         </a:spcAft>
                       </a:pPr>
                       <a:r>
-                        <a:rPr sz="1100" b="0">
+                        <a:rPr sz="1400" b="0">
                           <a:solidFill>
                             <a:srgbClr val="231F20"/>
                           </a:solidFill>
@@ -11028,7 +10682,7 @@
                         </a:spcAft>
                       </a:pPr>
                       <a:r>
-                        <a:rPr sz="1100" b="0">
+                        <a:rPr sz="1400" b="0">
                           <a:solidFill>
                             <a:srgbClr val="231F20"/>
                           </a:solidFill>
@@ -11055,7 +10709,7 @@
                         </a:spcAft>
                       </a:pPr>
                       <a:r>
-                        <a:rPr sz="1100" b="0">
+                        <a:rPr sz="1400" b="0">
                           <a:solidFill>
                             <a:srgbClr val="231F20"/>
                           </a:solidFill>
@@ -11072,7 +10726,7 @@
                   </a:tcPr>
                 </a:tc>
               </a:tr>
-              <a:tr h="330000">
+              <a:tr h="300000">
                 <a:tc>
                   <a:txBody>
                     <a:bodyPr wrap="square"/>
@@ -11084,7 +10738,7 @@
                         </a:spcAft>
                       </a:pPr>
                       <a:r>
-                        <a:rPr sz="1100" b="0">
+                        <a:rPr sz="1400" b="0">
                           <a:solidFill>
                             <a:srgbClr val="231F20"/>
                           </a:solidFill>
@@ -11111,7 +10765,7 @@
                         </a:spcAft>
                       </a:pPr>
                       <a:r>
-                        <a:rPr sz="1100" b="0">
+                        <a:rPr sz="1400" b="0">
                           <a:solidFill>
                             <a:srgbClr val="231F20"/>
                           </a:solidFill>
@@ -11138,7 +10792,7 @@
                         </a:spcAft>
                       </a:pPr>
                       <a:r>
-                        <a:rPr sz="1100" b="0">
+                        <a:rPr sz="1400" b="0">
                           <a:solidFill>
                             <a:srgbClr val="231F20"/>
                           </a:solidFill>
@@ -11165,7 +10819,7 @@
                         </a:spcAft>
                       </a:pPr>
                       <a:r>
-                        <a:rPr sz="1100" b="0">
+                        <a:rPr sz="1400" b="0">
                           <a:solidFill>
                             <a:srgbClr val="231F20"/>
                           </a:solidFill>
@@ -11186,6 +10840,93 @@
           </a:graphicData>
         </a:graphic>
       </p:graphicFrame>
+      <p:sp>
+        <p:nvSpPr>
+          <p:cNvPr id="5" name="TextBox 4"/>
+          <p:cNvSpPr txBox="1"/>
+          <p:nvPr/>
+        </p:nvSpPr>
+        <p:spPr>
+          <a:xfrm>
+            <a:off x="311700" y="2910000"/>
+            <a:ext cx="8520600" cy="2083500"/>
+          </a:xfrm>
+          <a:prstGeom prst="rect">
+            <a:avLst/>
+          </a:prstGeom>
+          <a:noFill/>
+        </p:spPr>
+        <p:txBody>
+          <a:bodyPr wrap="square">
+            <a:spAutoFit/>
+          </a:bodyPr>
+          <a:lstStyle/>
+          <a:p>
+            <a:pPr>
+              <a:spcAft>
+                <a:spcPts val="800"/>
+              </a:spcAft>
+            </a:pPr>
+            <a:r>
+              <a:rPr sz="1600" b="0">
+                <a:solidFill>
+                  <a:srgbClr val="231F20"/>
+                </a:solidFill>
+                <a:latin typeface="Proxima Nova"/>
+              </a:rPr>
+              <a:t>• Sozinhos, os três Random Forests acertam 85% a 86% do Benign-DoH</a:t>
+            </a:r>
+          </a:p>
+          <a:p>
+            <a:pPr>
+              <a:spcAft>
+                <a:spcPts val="800"/>
+              </a:spcAft>
+            </a:pPr>
+            <a:r>
+              <a:rPr sz="1600" b="0">
+                <a:solidFill>
+                  <a:srgbClr val="231F20"/>
+                </a:solidFill>
+                <a:latin typeface="Proxima Nova"/>
+              </a:rPr>
+              <a:t>• A perda acontece na regressão logística que os combina</a:t>
+            </a:r>
+          </a:p>
+          <a:p>
+            <a:pPr>
+              <a:spcAft>
+                <a:spcPts val="800"/>
+              </a:spcAft>
+            </a:pPr>
+            <a:r>
+              <a:rPr sz="1600" b="0">
+                <a:solidFill>
+                  <a:srgbClr val="231F20"/>
+                </a:solidFill>
+                <a:latin typeface="Proxima Nova"/>
+              </a:rPr>
+              <a:t>• No treino, quando os três dizem Benign-DoH, a classe real mais comum é Non-DoH</a:t>
+            </a:r>
+          </a:p>
+          <a:p>
+            <a:pPr>
+              <a:spcAft>
+                <a:spcPts val="800"/>
+              </a:spcAft>
+            </a:pPr>
+            <a:r>
+              <a:rPr sz="1600" b="0">
+                <a:solidFill>
+                  <a:srgbClr val="231F20"/>
+                </a:solidFill>
+                <a:latin typeface="Proxima Nova"/>
+              </a:rPr>
+              <a:t>• A acurácia esconde a classe rara: Benign-DoH é 1,70% do teste</a:t>
+            </a:r>
+          </a:p>
+        </p:txBody>
+      </p:sp>
     </p:spTree>
   </p:cSld>
   <p:clrMapOvr>
@@ -11284,104 +11025,17 @@
           </a:p>
         </p:txBody>
       </p:sp>
-      <p:sp>
-        <p:nvSpPr>
-          <p:cNvPr id="4" name="TextBox 3"/>
-          <p:cNvSpPr txBox="1"/>
-          <p:nvPr/>
-        </p:nvSpPr>
-        <p:spPr>
-          <a:xfrm>
-            <a:off x="311700" y="1010000"/>
-            <a:ext cx="4000000" cy="3900000"/>
-          </a:xfrm>
-          <a:prstGeom prst="rect">
-            <a:avLst/>
-          </a:prstGeom>
-          <a:noFill/>
-        </p:spPr>
-        <p:txBody>
-          <a:bodyPr wrap="square">
-            <a:spAutoFit/>
-          </a:bodyPr>
-          <a:lstStyle/>
-          <a:p>
-            <a:pPr>
-              <a:spcAft>
-                <a:spcPts val="800"/>
-              </a:spcAft>
-            </a:pPr>
-            <a:r>
-              <a:rPr sz="1600" b="0">
-                <a:solidFill>
-                  <a:srgbClr val="231F20"/>
-                </a:solidFill>
-                <a:latin typeface="Proxima Nova"/>
-              </a:rPr>
-              <a:t>• A Tabela II do artigo (99,98%) diverge da matriz do próprio artigo (99,78%)</a:t>
-            </a:r>
-          </a:p>
-          <a:p>
-            <a:pPr>
-              <a:spcAft>
-                <a:spcPts val="800"/>
-              </a:spcAft>
-            </a:pPr>
-            <a:r>
-              <a:rPr sz="1600" b="0">
-                <a:solidFill>
-                  <a:srgbClr val="231F20"/>
-                </a:solidFill>
-                <a:latin typeface="Proxima Nova"/>
-              </a:rPr>
-              <a:t>• A ordem dos modelos de comparação se mantém em F1 macro</a:t>
-            </a:r>
-          </a:p>
-          <a:p>
-            <a:pPr>
-              <a:spcAft>
-                <a:spcPts val="800"/>
-              </a:spcAft>
-            </a:pPr>
-            <a:r>
-              <a:rPr sz="1600" b="0">
-                <a:solidFill>
-                  <a:srgbClr val="231F20"/>
-                </a:solidFill>
-                <a:latin typeface="Proxima Nova"/>
-              </a:rPr>
-              <a:t>• Ferramenta de túnel (Seção VI-D): recall a menos de 2 pontos do artigo com profundidade variável</a:t>
-            </a:r>
-          </a:p>
-          <a:p>
-            <a:pPr>
-              <a:spcAft>
-                <a:spcPts val="800"/>
-              </a:spcAft>
-            </a:pPr>
-            <a:r>
-              <a:rPr sz="1600" b="0">
-                <a:solidFill>
-                  <a:srgbClr val="231F20"/>
-                </a:solidFill>
-                <a:latin typeface="Proxima Nova"/>
-              </a:rPr>
-              <a:t>• O artigo não descreve esse método: é leitura nossa</a:t>
-            </a:r>
-          </a:p>
-        </p:txBody>
-      </p:sp>
       <p:graphicFrame>
         <p:nvGraphicFramePr>
-          <p:cNvPr id="5" name="Table 4"/>
+          <p:cNvPr id="4" name="Table 3"/>
           <p:cNvGraphicFramePr>
             <a:graphicFrameLocks noGrp="1"/>
           </p:cNvGraphicFramePr>
           <p:nvPr/>
         </p:nvGraphicFramePr>
         <p:xfrm>
-          <a:off x="4500000" y="1010000"/>
-          <a:ext cx="4029038" cy="1980000"/>
+          <a:off x="311700" y="1010000"/>
+          <a:ext cx="7924157" cy="1800000"/>
         </p:xfrm>
         <a:graphic>
           <a:graphicData uri="http://schemas.openxmlformats.org/drawingml/2006/table">
@@ -11390,13 +11044,11 @@
                 <a:tableStyleId>{5C22544A-7EE6-4342-B048-85BDC9FD1C3A}</a:tableStyleId>
               </a:tblPr>
               <a:tblGrid>
-                <a:gridCol w="1047550"/>
-                <a:gridCol w="745372"/>
-                <a:gridCol w="745372"/>
-                <a:gridCol w="745372"/>
-                <a:gridCol w="745372"/>
+                <a:gridCol w="2694213"/>
+                <a:gridCol w="2614972"/>
+                <a:gridCol w="2614972"/>
               </a:tblGrid>
-              <a:tr h="330000">
+              <a:tr h="300000">
                 <a:tc>
                   <a:txBody>
                     <a:bodyPr wrap="square"/>
@@ -11408,13 +11060,13 @@
                         </a:spcAft>
                       </a:pPr>
                       <a:r>
-                        <a:rPr sz="1100" b="1">
+                        <a:rPr sz="1400" b="1">
                           <a:solidFill>
                             <a:srgbClr val="FFFFFF"/>
                           </a:solidFill>
                           <a:latin typeface="Proxima Nova"/>
                         </a:rPr>
-                        <a:t>Modelo</a:t>
+                        <a:t>Teste, em %</a:t>
                       </a:r>
                     </a:p>
                   </a:txBody>
@@ -11435,13 +11087,13 @@
                         </a:spcAft>
                       </a:pPr>
                       <a:r>
-                        <a:rPr sz="1100" b="1">
+                        <a:rPr sz="1400" b="1">
                           <a:solidFill>
                             <a:srgbClr val="FFFFFF"/>
                           </a:solidFill>
                           <a:latin typeface="Proxima Nova"/>
                         </a:rPr>
-                        <a:t>Acurácia Art.</a:t>
+                        <a:t>F1 (artigo)</a:t>
                       </a:r>
                     </a:p>
                   </a:txBody>
@@ -11462,13 +11114,13 @@
                         </a:spcAft>
                       </a:pPr>
                       <a:r>
-                        <a:rPr sz="1100" b="1">
+                        <a:rPr sz="1400" b="1">
                           <a:solidFill>
                             <a:srgbClr val="FFFFFF"/>
                           </a:solidFill>
                           <a:latin typeface="Proxima Nova"/>
                         </a:rPr>
-                        <a:t>Acurácia Rep.</a:t>
+                        <a:t>F1 macro (reprodução)</a:t>
                       </a:r>
                     </a:p>
                   </a:txBody>
@@ -11478,6 +11130,8 @@
                     </a:solidFill>
                   </a:tcPr>
                 </a:tc>
+              </a:tr>
+              <a:tr h="300000">
                 <a:tc>
                   <a:txBody>
                     <a:bodyPr wrap="square"/>
@@ -11489,63 +11143,7 @@
                         </a:spcAft>
                       </a:pPr>
                       <a:r>
-                        <a:rPr sz="1100" b="1">
-                          <a:solidFill>
-                            <a:srgbClr val="FFFFFF"/>
-                          </a:solidFill>
-                          <a:latin typeface="Proxima Nova"/>
-                        </a:rPr>
-                        <a:t>F1 Art.</a:t>
-                      </a:r>
-                    </a:p>
-                  </a:txBody>
-                  <a:tcPr marT="30000" marB="30000">
-                    <a:solidFill>
-                      <a:srgbClr val="231F20"/>
-                    </a:solidFill>
-                  </a:tcPr>
-                </a:tc>
-                <a:tc>
-                  <a:txBody>
-                    <a:bodyPr wrap="square"/>
-                    <a:lstStyle/>
-                    <a:p>
-                      <a:pPr>
-                        <a:spcAft>
-                          <a:spcPts val="0"/>
-                        </a:spcAft>
-                      </a:pPr>
-                      <a:r>
-                        <a:rPr sz="1100" b="1">
-                          <a:solidFill>
-                            <a:srgbClr val="FFFFFF"/>
-                          </a:solidFill>
-                          <a:latin typeface="Proxima Nova"/>
-                        </a:rPr>
-                        <a:t>F1 Macro</a:t>
-                      </a:r>
-                    </a:p>
-                  </a:txBody>
-                  <a:tcPr marT="30000" marB="30000">
-                    <a:solidFill>
-                      <a:srgbClr val="231F20"/>
-                    </a:solidFill>
-                  </a:tcPr>
-                </a:tc>
-              </a:tr>
-              <a:tr h="330000">
-                <a:tc>
-                  <a:txBody>
-                    <a:bodyPr wrap="square"/>
-                    <a:lstStyle/>
-                    <a:p>
-                      <a:pPr>
-                        <a:spcAft>
-                          <a:spcPts val="0"/>
-                        </a:spcAft>
-                      </a:pPr>
-                      <a:r>
-                        <a:rPr sz="1100" b="0">
+                        <a:rPr sz="1400" b="0">
                           <a:solidFill>
                             <a:srgbClr val="231F20"/>
                           </a:solidFill>
@@ -11572,61 +11170,7 @@
                         </a:spcAft>
                       </a:pPr>
                       <a:r>
-                        <a:rPr sz="1100" b="0">
-                          <a:solidFill>
-                            <a:srgbClr val="231F20"/>
-                          </a:solidFill>
-                          <a:latin typeface="Proxima Nova"/>
-                        </a:rPr>
-                        <a:t>97,70</a:t>
-                      </a:r>
-                    </a:p>
-                  </a:txBody>
-                  <a:tcPr marT="30000" marB="30000">
-                    <a:solidFill>
-                      <a:srgbClr val="FFFFFF"/>
-                    </a:solidFill>
-                  </a:tcPr>
-                </a:tc>
-                <a:tc>
-                  <a:txBody>
-                    <a:bodyPr wrap="square"/>
-                    <a:lstStyle/>
-                    <a:p>
-                      <a:pPr>
-                        <a:spcAft>
-                          <a:spcPts val="0"/>
-                        </a:spcAft>
-                      </a:pPr>
-                      <a:r>
-                        <a:rPr sz="1100" b="0">
-                          <a:solidFill>
-                            <a:srgbClr val="231F20"/>
-                          </a:solidFill>
-                          <a:latin typeface="Proxima Nova"/>
-                        </a:rPr>
-                        <a:t>97,23</a:t>
-                      </a:r>
-                    </a:p>
-                  </a:txBody>
-                  <a:tcPr marT="30000" marB="30000">
-                    <a:solidFill>
-                      <a:srgbClr val="FFFFFF"/>
-                    </a:solidFill>
-                  </a:tcPr>
-                </a:tc>
-                <a:tc>
-                  <a:txBody>
-                    <a:bodyPr wrap="square"/>
-                    <a:lstStyle/>
-                    <a:p>
-                      <a:pPr>
-                        <a:spcAft>
-                          <a:spcPts val="0"/>
-                        </a:spcAft>
-                      </a:pPr>
-                      <a:r>
-                        <a:rPr sz="1100" b="0">
+                        <a:rPr sz="1400" b="0">
                           <a:solidFill>
                             <a:srgbClr val="231F20"/>
                           </a:solidFill>
@@ -11653,7 +11197,7 @@
                         </a:spcAft>
                       </a:pPr>
                       <a:r>
-                        <a:rPr sz="1100" b="0">
+                        <a:rPr sz="1400" b="0">
                           <a:solidFill>
                             <a:srgbClr val="231F20"/>
                           </a:solidFill>
@@ -11670,7 +11214,7 @@
                   </a:tcPr>
                 </a:tc>
               </a:tr>
-              <a:tr h="330000">
+              <a:tr h="300000">
                 <a:tc>
                   <a:txBody>
                     <a:bodyPr wrap="square"/>
@@ -11682,7 +11226,7 @@
                         </a:spcAft>
                       </a:pPr>
                       <a:r>
-                        <a:rPr sz="1100" b="0">
+                        <a:rPr sz="1400" b="0">
                           <a:solidFill>
                             <a:srgbClr val="231F20"/>
                           </a:solidFill>
@@ -11709,61 +11253,7 @@
                         </a:spcAft>
                       </a:pPr>
                       <a:r>
-                        <a:rPr sz="1100" b="0">
-                          <a:solidFill>
-                            <a:srgbClr val="231F20"/>
-                          </a:solidFill>
-                          <a:latin typeface="Proxima Nova"/>
-                        </a:rPr>
-                        <a:t>99,27</a:t>
-                      </a:r>
-                    </a:p>
-                  </a:txBody>
-                  <a:tcPr marT="30000" marB="30000">
-                    <a:solidFill>
-                      <a:srgbClr val="EEEEEE"/>
-                    </a:solidFill>
-                  </a:tcPr>
-                </a:tc>
-                <a:tc>
-                  <a:txBody>
-                    <a:bodyPr wrap="square"/>
-                    <a:lstStyle/>
-                    <a:p>
-                      <a:pPr>
-                        <a:spcAft>
-                          <a:spcPts val="0"/>
-                        </a:spcAft>
-                      </a:pPr>
-                      <a:r>
-                        <a:rPr sz="1100" b="0">
-                          <a:solidFill>
-                            <a:srgbClr val="231F20"/>
-                          </a:solidFill>
-                          <a:latin typeface="Proxima Nova"/>
-                        </a:rPr>
-                        <a:t>99,31</a:t>
-                      </a:r>
-                    </a:p>
-                  </a:txBody>
-                  <a:tcPr marT="30000" marB="30000">
-                    <a:solidFill>
-                      <a:srgbClr val="EEEEEE"/>
-                    </a:solidFill>
-                  </a:tcPr>
-                </a:tc>
-                <a:tc>
-                  <a:txBody>
-                    <a:bodyPr wrap="square"/>
-                    <a:lstStyle/>
-                    <a:p>
-                      <a:pPr>
-                        <a:spcAft>
-                          <a:spcPts val="0"/>
-                        </a:spcAft>
-                      </a:pPr>
-                      <a:r>
-                        <a:rPr sz="1100" b="0">
+                        <a:rPr sz="1400" b="0">
                           <a:solidFill>
                             <a:srgbClr val="231F20"/>
                           </a:solidFill>
@@ -11790,7 +11280,7 @@
                         </a:spcAft>
                       </a:pPr>
                       <a:r>
-                        <a:rPr sz="1100" b="0">
+                        <a:rPr sz="1400" b="0">
                           <a:solidFill>
                             <a:srgbClr val="231F20"/>
                           </a:solidFill>
@@ -11807,7 +11297,7 @@
                   </a:tcPr>
                 </a:tc>
               </a:tr>
-              <a:tr h="330000">
+              <a:tr h="300000">
                 <a:tc>
                   <a:txBody>
                     <a:bodyPr wrap="square"/>
@@ -11819,7 +11309,7 @@
                         </a:spcAft>
                       </a:pPr>
                       <a:r>
-                        <a:rPr sz="1100" b="0">
+                        <a:rPr sz="1400" b="0">
                           <a:solidFill>
                             <a:srgbClr val="231F20"/>
                           </a:solidFill>
@@ -11846,61 +11336,7 @@
                         </a:spcAft>
                       </a:pPr>
                       <a:r>
-                        <a:rPr sz="1100" b="0">
-                          <a:solidFill>
-                            <a:srgbClr val="231F20"/>
-                          </a:solidFill>
-                          <a:latin typeface="Proxima Nova"/>
-                        </a:rPr>
-                        <a:t>99,98</a:t>
-                      </a:r>
-                    </a:p>
-                  </a:txBody>
-                  <a:tcPr marT="30000" marB="30000">
-                    <a:solidFill>
-                      <a:srgbClr val="FFFFFF"/>
-                    </a:solidFill>
-                  </a:tcPr>
-                </a:tc>
-                <a:tc>
-                  <a:txBody>
-                    <a:bodyPr wrap="square"/>
-                    <a:lstStyle/>
-                    <a:p>
-                      <a:pPr>
-                        <a:spcAft>
-                          <a:spcPts val="0"/>
-                        </a:spcAft>
-                      </a:pPr>
-                      <a:r>
-                        <a:rPr sz="1100" b="0">
-                          <a:solidFill>
-                            <a:srgbClr val="231F20"/>
-                          </a:solidFill>
-                          <a:latin typeface="Proxima Nova"/>
-                        </a:rPr>
-                        <a:t>99,42</a:t>
-                      </a:r>
-                    </a:p>
-                  </a:txBody>
-                  <a:tcPr marT="30000" marB="30000">
-                    <a:solidFill>
-                      <a:srgbClr val="FFFFFF"/>
-                    </a:solidFill>
-                  </a:tcPr>
-                </a:tc>
-                <a:tc>
-                  <a:txBody>
-                    <a:bodyPr wrap="square"/>
-                    <a:lstStyle/>
-                    <a:p>
-                      <a:pPr>
-                        <a:spcAft>
-                          <a:spcPts val="0"/>
-                        </a:spcAft>
-                      </a:pPr>
-                      <a:r>
-                        <a:rPr sz="1100" b="0">
+                        <a:rPr sz="1400" b="0">
                           <a:solidFill>
                             <a:srgbClr val="231F20"/>
                           </a:solidFill>
@@ -11927,7 +11363,7 @@
                         </a:spcAft>
                       </a:pPr>
                       <a:r>
-                        <a:rPr sz="1100" b="0">
+                        <a:rPr sz="1400" b="0">
                           <a:solidFill>
                             <a:srgbClr val="231F20"/>
                           </a:solidFill>
@@ -11944,7 +11380,7 @@
                   </a:tcPr>
                 </a:tc>
               </a:tr>
-              <a:tr h="330000">
+              <a:tr h="300000">
                 <a:tc>
                   <a:txBody>
                     <a:bodyPr wrap="square"/>
@@ -11956,7 +11392,7 @@
                         </a:spcAft>
                       </a:pPr>
                       <a:r>
-                        <a:rPr sz="1100" b="0">
+                        <a:rPr sz="1400" b="0">
                           <a:solidFill>
                             <a:srgbClr val="231F20"/>
                           </a:solidFill>
@@ -11983,61 +11419,7 @@
                         </a:spcAft>
                       </a:pPr>
                       <a:r>
-                        <a:rPr sz="1100" b="0">
-                          <a:solidFill>
-                            <a:srgbClr val="231F20"/>
-                          </a:solidFill>
-                          <a:latin typeface="Proxima Nova"/>
-                        </a:rPr>
-                        <a:t>99,98</a:t>
-                      </a:r>
-                    </a:p>
-                  </a:txBody>
-                  <a:tcPr marT="30000" marB="30000">
-                    <a:solidFill>
-                      <a:srgbClr val="EEEEEE"/>
-                    </a:solidFill>
-                  </a:tcPr>
-                </a:tc>
-                <a:tc>
-                  <a:txBody>
-                    <a:bodyPr wrap="square"/>
-                    <a:lstStyle/>
-                    <a:p>
-                      <a:pPr>
-                        <a:spcAft>
-                          <a:spcPts val="0"/>
-                        </a:spcAft>
-                      </a:pPr>
-                      <a:r>
-                        <a:rPr sz="1100" b="0">
-                          <a:solidFill>
-                            <a:srgbClr val="231F20"/>
-                          </a:solidFill>
-                          <a:latin typeface="Proxima Nova"/>
-                        </a:rPr>
-                        <a:t>97,79</a:t>
-                      </a:r>
-                    </a:p>
-                  </a:txBody>
-                  <a:tcPr marT="30000" marB="30000">
-                    <a:solidFill>
-                      <a:srgbClr val="EEEEEE"/>
-                    </a:solidFill>
-                  </a:tcPr>
-                </a:tc>
-                <a:tc>
-                  <a:txBody>
-                    <a:bodyPr wrap="square"/>
-                    <a:lstStyle/>
-                    <a:p>
-                      <a:pPr>
-                        <a:spcAft>
-                          <a:spcPts val="0"/>
-                        </a:spcAft>
-                      </a:pPr>
-                      <a:r>
-                        <a:rPr sz="1100" b="0">
+                        <a:rPr sz="1400" b="0">
                           <a:solidFill>
                             <a:srgbClr val="231F20"/>
                           </a:solidFill>
@@ -12064,7 +11446,7 @@
                         </a:spcAft>
                       </a:pPr>
                       <a:r>
-                        <a:rPr sz="1100" b="0">
+                        <a:rPr sz="1400" b="0">
                           <a:solidFill>
                             <a:srgbClr val="231F20"/>
                           </a:solidFill>
@@ -12081,7 +11463,7 @@
                   </a:tcPr>
                 </a:tc>
               </a:tr>
-              <a:tr h="330000">
+              <a:tr h="300000">
                 <a:tc>
                   <a:txBody>
                     <a:bodyPr wrap="square"/>
@@ -12093,7 +11475,7 @@
                         </a:spcAft>
                       </a:pPr>
                       <a:r>
-                        <a:rPr sz="1100" b="0">
+                        <a:rPr sz="1400" b="0">
                           <a:solidFill>
                             <a:srgbClr val="231F20"/>
                           </a:solidFill>
@@ -12120,61 +11502,7 @@
                         </a:spcAft>
                       </a:pPr>
                       <a:r>
-                        <a:rPr sz="1100" b="0">
-                          <a:solidFill>
-                            <a:srgbClr val="231F20"/>
-                          </a:solidFill>
-                          <a:latin typeface="Proxima Nova"/>
-                        </a:rPr>
-                        <a:t>99,98</a:t>
-                      </a:r>
-                    </a:p>
-                  </a:txBody>
-                  <a:tcPr marT="30000" marB="30000">
-                    <a:solidFill>
-                      <a:srgbClr val="FFFFFF"/>
-                    </a:solidFill>
-                  </a:tcPr>
-                </a:tc>
-                <a:tc>
-                  <a:txBody>
-                    <a:bodyPr wrap="square"/>
-                    <a:lstStyle/>
-                    <a:p>
-                      <a:pPr>
-                        <a:spcAft>
-                          <a:spcPts val="0"/>
-                        </a:spcAft>
-                      </a:pPr>
-                      <a:r>
-                        <a:rPr sz="1100" b="0">
-                          <a:solidFill>
-                            <a:srgbClr val="231F20"/>
-                          </a:solidFill>
-                          <a:latin typeface="Proxima Nova"/>
-                        </a:rPr>
-                        <a:t>99,64</a:t>
-                      </a:r>
-                    </a:p>
-                  </a:txBody>
-                  <a:tcPr marT="30000" marB="30000">
-                    <a:solidFill>
-                      <a:srgbClr val="FFFFFF"/>
-                    </a:solidFill>
-                  </a:tcPr>
-                </a:tc>
-                <a:tc>
-                  <a:txBody>
-                    <a:bodyPr wrap="square"/>
-                    <a:lstStyle/>
-                    <a:p>
-                      <a:pPr>
-                        <a:spcAft>
-                          <a:spcPts val="0"/>
-                        </a:spcAft>
-                      </a:pPr>
-                      <a:r>
-                        <a:rPr sz="1100" b="0">
+                        <a:rPr sz="1400" b="0">
                           <a:solidFill>
                             <a:srgbClr val="231F20"/>
                           </a:solidFill>
@@ -12201,7 +11529,7 @@
                         </a:spcAft>
                       </a:pPr>
                       <a:r>
-                        <a:rPr sz="1100" b="0">
+                        <a:rPr sz="1400" b="0">
                           <a:solidFill>
                             <a:srgbClr val="231F20"/>
                           </a:solidFill>
@@ -12222,6 +11550,93 @@
           </a:graphicData>
         </a:graphic>
       </p:graphicFrame>
+      <p:sp>
+        <p:nvSpPr>
+          <p:cNvPr id="5" name="TextBox 4"/>
+          <p:cNvSpPr txBox="1"/>
+          <p:nvPr/>
+        </p:nvSpPr>
+        <p:spPr>
+          <a:xfrm>
+            <a:off x="311700" y="2910000"/>
+            <a:ext cx="8520600" cy="2083500"/>
+          </a:xfrm>
+          <a:prstGeom prst="rect">
+            <a:avLst/>
+          </a:prstGeom>
+          <a:noFill/>
+        </p:spPr>
+        <p:txBody>
+          <a:bodyPr wrap="square">
+            <a:spAutoFit/>
+          </a:bodyPr>
+          <a:lstStyle/>
+          <a:p>
+            <a:pPr>
+              <a:spcAft>
+                <a:spcPts val="800"/>
+              </a:spcAft>
+            </a:pPr>
+            <a:r>
+              <a:rPr sz="1600" b="0">
+                <a:solidFill>
+                  <a:srgbClr val="231F20"/>
+                </a:solidFill>
+                <a:latin typeface="Proxima Nova"/>
+              </a:rPr>
+              <a:t>• A Tabela II do artigo (99,98%) diverge da matriz do próprio artigo (99,78%)</a:t>
+            </a:r>
+          </a:p>
+          <a:p>
+            <a:pPr>
+              <a:spcAft>
+                <a:spcPts val="800"/>
+              </a:spcAft>
+            </a:pPr>
+            <a:r>
+              <a:rPr sz="1600" b="0">
+                <a:solidFill>
+                  <a:srgbClr val="231F20"/>
+                </a:solidFill>
+                <a:latin typeface="Proxima Nova"/>
+              </a:rPr>
+              <a:t>• A ordem dos modelos de comparação se mantém em F1 macro</a:t>
+            </a:r>
+          </a:p>
+          <a:p>
+            <a:pPr>
+              <a:spcAft>
+                <a:spcPts val="800"/>
+              </a:spcAft>
+            </a:pPr>
+            <a:r>
+              <a:rPr sz="1600" b="0">
+                <a:solidFill>
+                  <a:srgbClr val="231F20"/>
+                </a:solidFill>
+                <a:latin typeface="Proxima Nova"/>
+              </a:rPr>
+              <a:t>• Ferramenta de túnel (Seção VI-D), prof. variável: recall a menos de 2 pontos do artigo</a:t>
+            </a:r>
+          </a:p>
+          <a:p>
+            <a:pPr>
+              <a:spcAft>
+                <a:spcPts val="800"/>
+              </a:spcAft>
+            </a:pPr>
+            <a:r>
+              <a:rPr sz="1600" b="0">
+                <a:solidFill>
+                  <a:srgbClr val="231F20"/>
+                </a:solidFill>
+                <a:latin typeface="Proxima Nova"/>
+              </a:rPr>
+              <a:t>• O artigo não descreve o método da Seção VI-D: é leitura nossa</a:t>
+            </a:r>
+          </a:p>
+        </p:txBody>
+      </p:sp>
     </p:spTree>
   </p:cSld>
   <p:clrMapOvr>
@@ -12320,112 +11735,9 @@
           </a:p>
         </p:txBody>
       </p:sp>
-      <p:sp>
-        <p:nvSpPr>
-          <p:cNvPr id="4" name="TextBox 3"/>
-          <p:cNvSpPr txBox="1"/>
-          <p:nvPr/>
-        </p:nvSpPr>
-        <p:spPr>
-          <a:xfrm>
-            <a:off x="311700" y="1010000"/>
-            <a:ext cx="4000000" cy="3900000"/>
-          </a:xfrm>
-          <a:prstGeom prst="rect">
-            <a:avLst/>
-          </a:prstGeom>
-          <a:noFill/>
-        </p:spPr>
-        <p:txBody>
-          <a:bodyPr wrap="square">
-            <a:spAutoFit/>
-          </a:bodyPr>
-          <a:lstStyle/>
-          <a:p>
-            <a:pPr>
-              <a:spcAft>
-                <a:spcPts val="800"/>
-              </a:spcAft>
-            </a:pPr>
-            <a:r>
-              <a:rPr sz="1600" b="0">
-                <a:solidFill>
-                  <a:srgbClr val="231F20"/>
-                </a:solidFill>
-                <a:latin typeface="Proxima Nova"/>
-              </a:rPr>
-              <a:t>• Artigo: Duration em primeiro. Aqui: PacketLengthMode, com larga margem</a:t>
-            </a:r>
-          </a:p>
-          <a:p>
-            <a:pPr>
-              <a:spcAft>
-                <a:spcPts val="800"/>
-              </a:spcAft>
-            </a:pPr>
-            <a:r>
-              <a:rPr sz="1600" b="0">
-                <a:solidFill>
-                  <a:srgbClr val="231F20"/>
-                </a:solidFill>
-                <a:latin typeface="Proxima Nova"/>
-              </a:rPr>
-              <a:t>• Correlação de Spearman com a Fig. 5: 0,62 e 0,51</a:t>
-            </a:r>
-          </a:p>
-          <a:p>
-            <a:pPr>
-              <a:spcAft>
-                <a:spcPts val="800"/>
-              </a:spcAft>
-            </a:pPr>
-            <a:r>
-              <a:rPr sz="1600" b="0">
-                <a:solidFill>
-                  <a:srgbClr val="231F20"/>
-                </a:solidFill>
-                <a:latin typeface="Proxima Nova"/>
-              </a:rPr>
-              <a:t>• Quatro valores de PacketLengthMode cobrem 99,84% do malicioso do CIRA</a:t>
-            </a:r>
-          </a:p>
-          <a:p>
-            <a:pPr>
-              <a:spcAft>
-                <a:spcPts val="800"/>
-              </a:spcAft>
-            </a:pPr>
-            <a:r>
-              <a:rPr sz="1600" b="0">
-                <a:solidFill>
-                  <a:srgbClr val="231F20"/>
-                </a:solidFill>
-                <a:latin typeface="Proxima Nova"/>
-              </a:rPr>
-              <a:t>• Duration: direção do artigo confirmada; o sinal troca em 33,13 s na nossa amostra</a:t>
-            </a:r>
-          </a:p>
-          <a:p>
-            <a:pPr>
-              <a:spcAft>
-                <a:spcPts val="800"/>
-              </a:spcAft>
-            </a:pPr>
-            <a:r>
-              <a:rPr sz="1600" b="0">
-                <a:solidFill>
-                  <a:srgbClr val="231F20"/>
-                </a:solidFill>
-                <a:latin typeface="Proxima Nova"/>
-              </a:rPr>
-              <a:t>• O SHAP explica os Random Forests base, não o empilhamento</a:t>
-            </a:r>
-          </a:p>
-        </p:txBody>
-      </p:sp>
       <p:pic>
         <p:nvPicPr>
-          <p:cNvPr id="5" name="Picture 4" descr="shap_importancia_cira.png"/>
+          <p:cNvPr id="4" name="Picture 3" descr="shap_importancia_cira.png"/>
           <p:cNvPicPr>
             <a:picLocks noChangeAspect="1"/>
           </p:cNvPicPr>
@@ -12447,6 +11759,109 @@
           </a:prstGeom>
         </p:spPr>
       </p:pic>
+      <p:sp>
+        <p:nvSpPr>
+          <p:cNvPr id="5" name="TextBox 4"/>
+          <p:cNvSpPr txBox="1"/>
+          <p:nvPr/>
+        </p:nvSpPr>
+        <p:spPr>
+          <a:xfrm>
+            <a:off x="311700" y="1010000"/>
+            <a:ext cx="4000000" cy="3900000"/>
+          </a:xfrm>
+          <a:prstGeom prst="rect">
+            <a:avLst/>
+          </a:prstGeom>
+          <a:noFill/>
+        </p:spPr>
+        <p:txBody>
+          <a:bodyPr wrap="square">
+            <a:spAutoFit/>
+          </a:bodyPr>
+          <a:lstStyle/>
+          <a:p>
+            <a:pPr>
+              <a:spcAft>
+                <a:spcPts val="800"/>
+              </a:spcAft>
+            </a:pPr>
+            <a:r>
+              <a:rPr sz="1600" b="0">
+                <a:solidFill>
+                  <a:srgbClr val="231F20"/>
+                </a:solidFill>
+                <a:latin typeface="Proxima Nova"/>
+              </a:rPr>
+              <a:t>• Artigo: Duration em primeiro. Aqui: PacketLengthMode, com larga margem</a:t>
+            </a:r>
+          </a:p>
+          <a:p>
+            <a:pPr>
+              <a:spcAft>
+                <a:spcPts val="800"/>
+              </a:spcAft>
+            </a:pPr>
+            <a:r>
+              <a:rPr sz="1600" b="0">
+                <a:solidFill>
+                  <a:srgbClr val="231F20"/>
+                </a:solidFill>
+                <a:latin typeface="Proxima Nova"/>
+              </a:rPr>
+              <a:t>• Spearman com a Fig. 5: 0,62 (prof. 5) e 0,51 (prof. variável)</a:t>
+            </a:r>
+          </a:p>
+          <a:p>
+            <a:pPr>
+              <a:spcAft>
+                <a:spcPts val="800"/>
+              </a:spcAft>
+            </a:pPr>
+            <a:r>
+              <a:rPr sz="1600" b="0">
+                <a:solidFill>
+                  <a:srgbClr val="231F20"/>
+                </a:solidFill>
+                <a:latin typeface="Proxima Nova"/>
+              </a:rPr>
+              <a:t>• Quatro valores de PacketLengthMode cobrem 99,84% do malicioso do CIRA</a:t>
+            </a:r>
+          </a:p>
+          <a:p>
+            <a:pPr>
+              <a:spcAft>
+                <a:spcPts val="800"/>
+              </a:spcAft>
+            </a:pPr>
+            <a:r>
+              <a:rPr sz="1600" b="0">
+                <a:solidFill>
+                  <a:srgbClr val="231F20"/>
+                </a:solidFill>
+                <a:latin typeface="Proxima Nova"/>
+              </a:rPr>
+              <a:t>• Duration: direção do artigo observada; o sinal troca em 33,13 s na nossa amostra</a:t>
+            </a:r>
+          </a:p>
+          <a:p>
+            <a:pPr>
+              <a:spcAft>
+                <a:spcPts val="800"/>
+              </a:spcAft>
+            </a:pPr>
+            <a:r>
+              <a:rPr sz="1600" b="0">
+                <a:solidFill>
+                  <a:srgbClr val="231F20"/>
+                </a:solidFill>
+                <a:latin typeface="Proxima Nova"/>
+              </a:rPr>
+              <a:t>• O SHAP explica os Random Forests base, não o empilhamento</a:t>
+            </a:r>
+          </a:p>
+        </p:txBody>
+      </p:sp>
     </p:spTree>
   </p:cSld>
   <p:clrMapOvr>
@@ -12545,96 +11960,9 @@
           </a:p>
         </p:txBody>
       </p:sp>
-      <p:sp>
-        <p:nvSpPr>
-          <p:cNvPr id="4" name="TextBox 3"/>
-          <p:cNvSpPr txBox="1"/>
-          <p:nvPr/>
-        </p:nvSpPr>
-        <p:spPr>
-          <a:xfrm>
-            <a:off x="311700" y="1010000"/>
-            <a:ext cx="4000000" cy="3900000"/>
-          </a:xfrm>
-          <a:prstGeom prst="rect">
-            <a:avLst/>
-          </a:prstGeom>
-          <a:noFill/>
-        </p:spPr>
-        <p:txBody>
-          <a:bodyPr wrap="square">
-            <a:spAutoFit/>
-          </a:bodyPr>
-          <a:lstStyle/>
-          <a:p>
-            <a:pPr>
-              <a:spcAft>
-                <a:spcPts val="800"/>
-              </a:spcAft>
-            </a:pPr>
-            <a:r>
-              <a:rPr sz="1600" b="0">
-                <a:solidFill>
-                  <a:srgbClr val="231F20"/>
-                </a:solidFill>
-                <a:latin typeface="Proxima Nova"/>
-              </a:rPr>
-              <a:t>• A: sistema do artigo, profundidade variável. F1 macro de 96,56 ± 0,12%</a:t>
-            </a:r>
-          </a:p>
-          <a:p>
-            <a:pPr>
-              <a:spcAft>
-                <a:spcPts val="800"/>
-              </a:spcAft>
-            </a:pPr>
-            <a:r>
-              <a:rPr sz="1600" b="0">
-                <a:solidFill>
-                  <a:srgbClr val="231F20"/>
-                </a:solidFill>
-                <a:latin typeface="Proxima Nova"/>
-              </a:rPr>
-              <a:t>• B e C: Random Forest único com SMOTE; M1M2: a nossa modificação</a:t>
-            </a:r>
-          </a:p>
-          <a:p>
-            <a:pPr>
-              <a:spcAft>
-                <a:spcPts val="800"/>
-              </a:spcAft>
-            </a:pPr>
-            <a:r>
-              <a:rPr sz="1600" b="0">
-                <a:solidFill>
-                  <a:srgbClr val="231F20"/>
-                </a:solidFill>
-                <a:latin typeface="Proxima Nova"/>
-              </a:rPr>
-              <a:t>• 13,64% do teste repete um vetor do treino; sem eles, os vereditos não mudam</a:t>
-            </a:r>
-          </a:p>
-          <a:p>
-            <a:pPr>
-              <a:spcAft>
-                <a:spcPts val="800"/>
-              </a:spcAft>
-            </a:pPr>
-            <a:r>
-              <a:rPr sz="1600" b="0">
-                <a:solidFill>
-                  <a:srgbClr val="231F20"/>
-                </a:solidFill>
-                <a:latin typeface="Proxima Nova"/>
-              </a:rPr>
-              <a:t>• Folds por máquina: recall de Benign-DoH cai de 93,07% para 31,10%</a:t>
-            </a:r>
-          </a:p>
-        </p:txBody>
-      </p:sp>
       <p:pic>
         <p:nvPicPr>
-          <p:cNvPr id="5" name="Picture 4" descr="corrigido_seeds.png"/>
+          <p:cNvPr id="4" name="Picture 3" descr="corrigido_seeds.png"/>
           <p:cNvPicPr>
             <a:picLocks noChangeAspect="1"/>
           </p:cNvPicPr>
@@ -12656,6 +11984,93 @@
           </a:prstGeom>
         </p:spPr>
       </p:pic>
+      <p:sp>
+        <p:nvSpPr>
+          <p:cNvPr id="5" name="TextBox 4"/>
+          <p:cNvSpPr txBox="1"/>
+          <p:nvPr/>
+        </p:nvSpPr>
+        <p:spPr>
+          <a:xfrm>
+            <a:off x="311700" y="1010000"/>
+            <a:ext cx="4000000" cy="3900000"/>
+          </a:xfrm>
+          <a:prstGeom prst="rect">
+            <a:avLst/>
+          </a:prstGeom>
+          <a:noFill/>
+        </p:spPr>
+        <p:txBody>
+          <a:bodyPr wrap="square">
+            <a:spAutoFit/>
+          </a:bodyPr>
+          <a:lstStyle/>
+          <a:p>
+            <a:pPr>
+              <a:spcAft>
+                <a:spcPts val="800"/>
+              </a:spcAft>
+            </a:pPr>
+            <a:r>
+              <a:rPr sz="1600" b="0">
+                <a:solidFill>
+                  <a:srgbClr val="231F20"/>
+                </a:solidFill>
+                <a:latin typeface="Proxima Nova"/>
+              </a:rPr>
+              <a:t>• A: sistema do artigo, profundidade variável. F1 macro de 96,56 ± 0,12%</a:t>
+            </a:r>
+          </a:p>
+          <a:p>
+            <a:pPr>
+              <a:spcAft>
+                <a:spcPts val="800"/>
+              </a:spcAft>
+            </a:pPr>
+            <a:r>
+              <a:rPr sz="1600" b="0">
+                <a:solidFill>
+                  <a:srgbClr val="231F20"/>
+                </a:solidFill>
+                <a:latin typeface="Proxima Nova"/>
+              </a:rPr>
+              <a:t>• B e C: Random Forest único com SMOTE; M1M2: a nossa modificação</a:t>
+            </a:r>
+          </a:p>
+          <a:p>
+            <a:pPr>
+              <a:spcAft>
+                <a:spcPts val="800"/>
+              </a:spcAft>
+            </a:pPr>
+            <a:r>
+              <a:rPr sz="1600" b="0">
+                <a:solidFill>
+                  <a:srgbClr val="231F20"/>
+                </a:solidFill>
+                <a:latin typeface="Proxima Nova"/>
+              </a:rPr>
+              <a:t>• 13,64% do teste repete um vetor do treino; sem eles, os vereditos não mudam</a:t>
+            </a:r>
+          </a:p>
+          <a:p>
+            <a:pPr>
+              <a:spcAft>
+                <a:spcPts val="800"/>
+              </a:spcAft>
+            </a:pPr>
+            <a:r>
+              <a:rPr sz="1600" b="0">
+                <a:solidFill>
+                  <a:srgbClr val="231F20"/>
+                </a:solidFill>
+                <a:latin typeface="Proxima Nova"/>
+              </a:rPr>
+              <a:t>• Folds por máquina: recall de Benign-DoH cai de 93,07% para 31,10%</a:t>
+            </a:r>
+          </a:p>
+        </p:txBody>
+      </p:sp>
     </p:spTree>
   </p:cSld>
   <p:clrMapOvr>

</xml_diff>

<commit_message>
docs(report): alinha slides e roteiro às correções do relatório
</commit_message>
<xml_diff>
--- a/project/report/apresentacao.pptx
+++ b/project/report/apresentacao.pptx
@@ -919,7 +919,7 @@
           </a:p>
           <a:p>
             <a:r>
-              <a:t>Tempo: 1,6 vez no CIRA e 2,3 vezes no combinado; o tempo de A no CIRA foi medido sob outra carga e, reajustado, é 112,5 s (2,3 vezes).</a:t>
+              <a:t>Tempo: 1,6 vez no CIRA e cerca de 2,2 vezes no combinado; o tempo de A no CIRA foi medido sob outra carga e, reajustado, é 112,5 s (2,3 vezes).</a:t>
             </a:r>
           </a:p>
           <a:p>
@@ -1274,7 +1274,7 @@
           </a:p>
           <a:p>
             <a:r>
-              <a:t>Os experimentos seguintes usam a leitura de profundidade variável como base, porque a outra não prediz uma das classes.</a:t>
+              <a:t>Os experimentos seguintes usam a leitura de profundidade variável como base, porque a outra tem recall 0 em uma das classes.</a:t>
             </a:r>
           </a:p>
           <a:p>
@@ -8255,7 +8255,7 @@
                 </a:solidFill>
                 <a:latin typeface="Proxima Nova"/>
               </a:rPr>
-              <a:t>• Um Random Forest único com peso de classe supera o empilhamento em F1 macro, por 0,5 ponto</a:t>
+              <a:t>• Um Random Forest único com peso de classe supera o empilhamento em F1 macro, por cerca de meio ponto</a:t>
             </a:r>
           </a:p>
           <a:p>

</xml_diff>